<commit_message>
Update psweep script to save information on plasmid-free cells
</commit_message>
<xml_diff>
--- a/figures/edited/fig2_edited.pptx
+++ b/figures/edited/fig2_edited.pptx
@@ -2,12 +2,12 @@
 <file path=ppt/presentation.xml><?xml version="1.0" encoding="utf-8"?>
 <p:presentation xmlns:a="http://schemas.openxmlformats.org/drawingml/2006/main" xmlns:r="http://schemas.openxmlformats.org/officeDocument/2006/relationships" xmlns:p="http://schemas.openxmlformats.org/presentationml/2006/main" saveSubsetFonts="1" autoCompressPictures="0">
   <p:sldMasterIdLst>
-    <p:sldMasterId id="2147483696" r:id="rId1"/>
+    <p:sldMasterId id="2147483744" r:id="rId1"/>
   </p:sldMasterIdLst>
   <p:sldIdLst>
     <p:sldId id="256" r:id="rId2"/>
   </p:sldIdLst>
-  <p:sldSz cx="4572000" cy="3657600"/>
+  <p:sldSz cx="4572000" cy="3886200"/>
   <p:notesSz cx="6858000" cy="9144000"/>
   <p:defaultTextStyle>
     <a:defPPr>
@@ -141,8 +141,8 @@
         </p:nvSpPr>
         <p:spPr>
           <a:xfrm>
-            <a:off x="342900" y="598593"/>
-            <a:ext cx="3886200" cy="1273387"/>
+            <a:off x="342900" y="636006"/>
+            <a:ext cx="3886200" cy="1352973"/>
           </a:xfrm>
         </p:spPr>
         <p:txBody>
@@ -173,8 +173,8 @@
         </p:nvSpPr>
         <p:spPr>
           <a:xfrm>
-            <a:off x="571500" y="1921087"/>
-            <a:ext cx="3429000" cy="883073"/>
+            <a:off x="571500" y="2041155"/>
+            <a:ext cx="3429000" cy="938265"/>
           </a:xfrm>
         </p:spPr>
         <p:txBody>
@@ -243,7 +243,7 @@
           <a:p>
             <a:fld id="{6640EBF9-9B9C-C849-9F58-C2602C067150}" type="datetimeFigureOut">
               <a:rPr lang="en-US" smtClean="0"/>
-              <a:t>6/1/26</a:t>
+              <a:t>7/2/26</a:t>
             </a:fld>
             <a:endParaRPr lang="en-US"/>
           </a:p>
@@ -294,7 +294,7 @@
     </p:spTree>
     <p:extLst>
       <p:ext uri="{BB962C8B-B14F-4D97-AF65-F5344CB8AC3E}">
-        <p14:creationId xmlns:p14="http://schemas.microsoft.com/office/powerpoint/2010/main" val="3347062202"/>
+        <p14:creationId xmlns:p14="http://schemas.microsoft.com/office/powerpoint/2010/main" val="1469120225"/>
       </p:ext>
     </p:extLst>
   </p:cSld>
@@ -413,7 +413,7 @@
           <a:p>
             <a:fld id="{6640EBF9-9B9C-C849-9F58-C2602C067150}" type="datetimeFigureOut">
               <a:rPr lang="en-US" smtClean="0"/>
-              <a:t>6/1/26</a:t>
+              <a:t>7/2/26</a:t>
             </a:fld>
             <a:endParaRPr lang="en-US"/>
           </a:p>
@@ -464,7 +464,7 @@
     </p:spTree>
     <p:extLst>
       <p:ext uri="{BB962C8B-B14F-4D97-AF65-F5344CB8AC3E}">
-        <p14:creationId xmlns:p14="http://schemas.microsoft.com/office/powerpoint/2010/main" val="1454303287"/>
+        <p14:creationId xmlns:p14="http://schemas.microsoft.com/office/powerpoint/2010/main" val="149163161"/>
       </p:ext>
     </p:extLst>
   </p:cSld>
@@ -503,8 +503,8 @@
         </p:nvSpPr>
         <p:spPr>
           <a:xfrm>
-            <a:off x="3271838" y="194733"/>
-            <a:ext cx="985838" cy="3099647"/>
+            <a:off x="3271838" y="206904"/>
+            <a:ext cx="985838" cy="3293375"/>
           </a:xfrm>
         </p:spPr>
         <p:txBody>
@@ -531,8 +531,8 @@
         </p:nvSpPr>
         <p:spPr>
           <a:xfrm>
-            <a:off x="314325" y="194733"/>
-            <a:ext cx="2900363" cy="3099647"/>
+            <a:off x="314325" y="206904"/>
+            <a:ext cx="2900363" cy="3293375"/>
           </a:xfrm>
         </p:spPr>
         <p:txBody>
@@ -593,7 +593,7 @@
           <a:p>
             <a:fld id="{6640EBF9-9B9C-C849-9F58-C2602C067150}" type="datetimeFigureOut">
               <a:rPr lang="en-US" smtClean="0"/>
-              <a:t>6/1/26</a:t>
+              <a:t>7/2/26</a:t>
             </a:fld>
             <a:endParaRPr lang="en-US"/>
           </a:p>
@@ -644,7 +644,7 @@
     </p:spTree>
     <p:extLst>
       <p:ext uri="{BB962C8B-B14F-4D97-AF65-F5344CB8AC3E}">
-        <p14:creationId xmlns:p14="http://schemas.microsoft.com/office/powerpoint/2010/main" val="3117216936"/>
+        <p14:creationId xmlns:p14="http://schemas.microsoft.com/office/powerpoint/2010/main" val="1613608237"/>
       </p:ext>
     </p:extLst>
   </p:cSld>
@@ -763,7 +763,7 @@
           <a:p>
             <a:fld id="{6640EBF9-9B9C-C849-9F58-C2602C067150}" type="datetimeFigureOut">
               <a:rPr lang="en-US" smtClean="0"/>
-              <a:t>6/1/26</a:t>
+              <a:t>7/2/26</a:t>
             </a:fld>
             <a:endParaRPr lang="en-US"/>
           </a:p>
@@ -814,7 +814,7 @@
     </p:spTree>
     <p:extLst>
       <p:ext uri="{BB962C8B-B14F-4D97-AF65-F5344CB8AC3E}">
-        <p14:creationId xmlns:p14="http://schemas.microsoft.com/office/powerpoint/2010/main" val="2975115619"/>
+        <p14:creationId xmlns:p14="http://schemas.microsoft.com/office/powerpoint/2010/main" val="1174351372"/>
       </p:ext>
     </p:extLst>
   </p:cSld>
@@ -853,8 +853,8 @@
         </p:nvSpPr>
         <p:spPr>
           <a:xfrm>
-            <a:off x="311944" y="911861"/>
-            <a:ext cx="3943350" cy="1521460"/>
+            <a:off x="311944" y="968852"/>
+            <a:ext cx="3943350" cy="1616551"/>
           </a:xfrm>
         </p:spPr>
         <p:txBody>
@@ -885,8 +885,8 @@
         </p:nvSpPr>
         <p:spPr>
           <a:xfrm>
-            <a:off x="311944" y="2447714"/>
-            <a:ext cx="3943350" cy="800100"/>
+            <a:off x="311944" y="2600697"/>
+            <a:ext cx="3943350" cy="850106"/>
           </a:xfrm>
         </p:spPr>
         <p:txBody>
@@ -1009,7 +1009,7 @@
           <a:p>
             <a:fld id="{6640EBF9-9B9C-C849-9F58-C2602C067150}" type="datetimeFigureOut">
               <a:rPr lang="en-US" smtClean="0"/>
-              <a:t>6/1/26</a:t>
+              <a:t>7/2/26</a:t>
             </a:fld>
             <a:endParaRPr lang="en-US"/>
           </a:p>
@@ -1060,7 +1060,7 @@
     </p:spTree>
     <p:extLst>
       <p:ext uri="{BB962C8B-B14F-4D97-AF65-F5344CB8AC3E}">
-        <p14:creationId xmlns:p14="http://schemas.microsoft.com/office/powerpoint/2010/main" val="1152845148"/>
+        <p14:creationId xmlns:p14="http://schemas.microsoft.com/office/powerpoint/2010/main" val="1353195730"/>
       </p:ext>
     </p:extLst>
   </p:cSld>
@@ -1122,8 +1122,8 @@
         </p:nvSpPr>
         <p:spPr>
           <a:xfrm>
-            <a:off x="314325" y="973666"/>
-            <a:ext cx="1943100" cy="2320714"/>
+            <a:off x="314325" y="1034521"/>
+            <a:ext cx="1943100" cy="2465758"/>
           </a:xfrm>
         </p:spPr>
         <p:txBody>
@@ -1179,8 +1179,8 @@
         </p:nvSpPr>
         <p:spPr>
           <a:xfrm>
-            <a:off x="2314575" y="973666"/>
-            <a:ext cx="1943100" cy="2320714"/>
+            <a:off x="2314575" y="1034521"/>
+            <a:ext cx="1943100" cy="2465758"/>
           </a:xfrm>
         </p:spPr>
         <p:txBody>
@@ -1241,7 +1241,7 @@
           <a:p>
             <a:fld id="{6640EBF9-9B9C-C849-9F58-C2602C067150}" type="datetimeFigureOut">
               <a:rPr lang="en-US" smtClean="0"/>
-              <a:t>6/1/26</a:t>
+              <a:t>7/2/26</a:t>
             </a:fld>
             <a:endParaRPr lang="en-US"/>
           </a:p>
@@ -1292,7 +1292,7 @@
     </p:spTree>
     <p:extLst>
       <p:ext uri="{BB962C8B-B14F-4D97-AF65-F5344CB8AC3E}">
-        <p14:creationId xmlns:p14="http://schemas.microsoft.com/office/powerpoint/2010/main" val="587037709"/>
+        <p14:creationId xmlns:p14="http://schemas.microsoft.com/office/powerpoint/2010/main" val="367761067"/>
       </p:ext>
     </p:extLst>
   </p:cSld>
@@ -1331,8 +1331,8 @@
         </p:nvSpPr>
         <p:spPr>
           <a:xfrm>
-            <a:off x="314920" y="194734"/>
-            <a:ext cx="3943350" cy="706967"/>
+            <a:off x="314920" y="206905"/>
+            <a:ext cx="3943350" cy="751152"/>
           </a:xfrm>
         </p:spPr>
         <p:txBody>
@@ -1359,8 +1359,8 @@
         </p:nvSpPr>
         <p:spPr>
           <a:xfrm>
-            <a:off x="314921" y="896620"/>
-            <a:ext cx="1934170" cy="439420"/>
+            <a:off x="314921" y="952659"/>
+            <a:ext cx="1934170" cy="466883"/>
           </a:xfrm>
         </p:spPr>
         <p:txBody>
@@ -1424,8 +1424,8 @@
         </p:nvSpPr>
         <p:spPr>
           <a:xfrm>
-            <a:off x="314921" y="1336040"/>
-            <a:ext cx="1934170" cy="1965114"/>
+            <a:off x="314921" y="1419543"/>
+            <a:ext cx="1934170" cy="2087933"/>
           </a:xfrm>
         </p:spPr>
         <p:txBody>
@@ -1481,8 +1481,8 @@
         </p:nvSpPr>
         <p:spPr>
           <a:xfrm>
-            <a:off x="2314575" y="896620"/>
-            <a:ext cx="1943696" cy="439420"/>
+            <a:off x="2314575" y="952659"/>
+            <a:ext cx="1943696" cy="466883"/>
           </a:xfrm>
         </p:spPr>
         <p:txBody>
@@ -1546,8 +1546,8 @@
         </p:nvSpPr>
         <p:spPr>
           <a:xfrm>
-            <a:off x="2314575" y="1336040"/>
-            <a:ext cx="1943696" cy="1965114"/>
+            <a:off x="2314575" y="1419543"/>
+            <a:ext cx="1943696" cy="2087933"/>
           </a:xfrm>
         </p:spPr>
         <p:txBody>
@@ -1608,7 +1608,7 @@
           <a:p>
             <a:fld id="{6640EBF9-9B9C-C849-9F58-C2602C067150}" type="datetimeFigureOut">
               <a:rPr lang="en-US" smtClean="0"/>
-              <a:t>6/1/26</a:t>
+              <a:t>7/2/26</a:t>
             </a:fld>
             <a:endParaRPr lang="en-US"/>
           </a:p>
@@ -1659,7 +1659,7 @@
     </p:spTree>
     <p:extLst>
       <p:ext uri="{BB962C8B-B14F-4D97-AF65-F5344CB8AC3E}">
-        <p14:creationId xmlns:p14="http://schemas.microsoft.com/office/powerpoint/2010/main" val="302833572"/>
+        <p14:creationId xmlns:p14="http://schemas.microsoft.com/office/powerpoint/2010/main" val="4232152080"/>
       </p:ext>
     </p:extLst>
   </p:cSld>
@@ -1726,7 +1726,7 @@
           <a:p>
             <a:fld id="{6640EBF9-9B9C-C849-9F58-C2602C067150}" type="datetimeFigureOut">
               <a:rPr lang="en-US" smtClean="0"/>
-              <a:t>6/1/26</a:t>
+              <a:t>7/2/26</a:t>
             </a:fld>
             <a:endParaRPr lang="en-US"/>
           </a:p>
@@ -1777,7 +1777,7 @@
     </p:spTree>
     <p:extLst>
       <p:ext uri="{BB962C8B-B14F-4D97-AF65-F5344CB8AC3E}">
-        <p14:creationId xmlns:p14="http://schemas.microsoft.com/office/powerpoint/2010/main" val="750818152"/>
+        <p14:creationId xmlns:p14="http://schemas.microsoft.com/office/powerpoint/2010/main" val="1140076218"/>
       </p:ext>
     </p:extLst>
   </p:cSld>
@@ -1821,7 +1821,7 @@
           <a:p>
             <a:fld id="{6640EBF9-9B9C-C849-9F58-C2602C067150}" type="datetimeFigureOut">
               <a:rPr lang="en-US" smtClean="0"/>
-              <a:t>6/1/26</a:t>
+              <a:t>7/2/26</a:t>
             </a:fld>
             <a:endParaRPr lang="en-US"/>
           </a:p>
@@ -1872,7 +1872,7 @@
     </p:spTree>
     <p:extLst>
       <p:ext uri="{BB962C8B-B14F-4D97-AF65-F5344CB8AC3E}">
-        <p14:creationId xmlns:p14="http://schemas.microsoft.com/office/powerpoint/2010/main" val="3545623919"/>
+        <p14:creationId xmlns:p14="http://schemas.microsoft.com/office/powerpoint/2010/main" val="1434326638"/>
       </p:ext>
     </p:extLst>
   </p:cSld>
@@ -1911,8 +1911,8 @@
         </p:nvSpPr>
         <p:spPr>
           <a:xfrm>
-            <a:off x="314921" y="243840"/>
-            <a:ext cx="1474589" cy="853440"/>
+            <a:off x="314921" y="259080"/>
+            <a:ext cx="1474589" cy="906780"/>
           </a:xfrm>
         </p:spPr>
         <p:txBody>
@@ -1943,8 +1943,8 @@
         </p:nvSpPr>
         <p:spPr>
           <a:xfrm>
-            <a:off x="1943695" y="526627"/>
-            <a:ext cx="2314575" cy="2599267"/>
+            <a:off x="1943695" y="559542"/>
+            <a:ext cx="2314575" cy="2761721"/>
           </a:xfrm>
         </p:spPr>
         <p:txBody>
@@ -2028,8 +2028,8 @@
         </p:nvSpPr>
         <p:spPr>
           <a:xfrm>
-            <a:off x="314921" y="1097280"/>
-            <a:ext cx="1474589" cy="2032847"/>
+            <a:off x="314921" y="1165860"/>
+            <a:ext cx="1474589" cy="2159900"/>
           </a:xfrm>
         </p:spPr>
         <p:txBody>
@@ -2098,7 +2098,7 @@
           <a:p>
             <a:fld id="{6640EBF9-9B9C-C849-9F58-C2602C067150}" type="datetimeFigureOut">
               <a:rPr lang="en-US" smtClean="0"/>
-              <a:t>6/1/26</a:t>
+              <a:t>7/2/26</a:t>
             </a:fld>
             <a:endParaRPr lang="en-US"/>
           </a:p>
@@ -2149,7 +2149,7 @@
     </p:spTree>
     <p:extLst>
       <p:ext uri="{BB962C8B-B14F-4D97-AF65-F5344CB8AC3E}">
-        <p14:creationId xmlns:p14="http://schemas.microsoft.com/office/powerpoint/2010/main" val="798743814"/>
+        <p14:creationId xmlns:p14="http://schemas.microsoft.com/office/powerpoint/2010/main" val="618665360"/>
       </p:ext>
     </p:extLst>
   </p:cSld>
@@ -2188,8 +2188,8 @@
         </p:nvSpPr>
         <p:spPr>
           <a:xfrm>
-            <a:off x="314921" y="243840"/>
-            <a:ext cx="1474589" cy="853440"/>
+            <a:off x="314921" y="259080"/>
+            <a:ext cx="1474589" cy="906780"/>
           </a:xfrm>
         </p:spPr>
         <p:txBody>
@@ -2220,8 +2220,8 @@
         </p:nvSpPr>
         <p:spPr>
           <a:xfrm>
-            <a:off x="1943695" y="526627"/>
-            <a:ext cx="2314575" cy="2599267"/>
+            <a:off x="1943695" y="559542"/>
+            <a:ext cx="2314575" cy="2761721"/>
           </a:xfrm>
         </p:spPr>
         <p:txBody>
@@ -2285,8 +2285,8 @@
         </p:nvSpPr>
         <p:spPr>
           <a:xfrm>
-            <a:off x="314921" y="1097280"/>
-            <a:ext cx="1474589" cy="2032847"/>
+            <a:off x="314921" y="1165860"/>
+            <a:ext cx="1474589" cy="2159900"/>
           </a:xfrm>
         </p:spPr>
         <p:txBody>
@@ -2355,7 +2355,7 @@
           <a:p>
             <a:fld id="{6640EBF9-9B9C-C849-9F58-C2602C067150}" type="datetimeFigureOut">
               <a:rPr lang="en-US" smtClean="0"/>
-              <a:t>6/1/26</a:t>
+              <a:t>7/2/26</a:t>
             </a:fld>
             <a:endParaRPr lang="en-US"/>
           </a:p>
@@ -2406,7 +2406,7 @@
     </p:spTree>
     <p:extLst>
       <p:ext uri="{BB962C8B-B14F-4D97-AF65-F5344CB8AC3E}">
-        <p14:creationId xmlns:p14="http://schemas.microsoft.com/office/powerpoint/2010/main" val="309232459"/>
+        <p14:creationId xmlns:p14="http://schemas.microsoft.com/office/powerpoint/2010/main" val="1609889639"/>
       </p:ext>
     </p:extLst>
   </p:cSld>
@@ -2450,8 +2450,8 @@
         </p:nvSpPr>
         <p:spPr>
           <a:xfrm>
-            <a:off x="314325" y="194734"/>
-            <a:ext cx="3943350" cy="706967"/>
+            <a:off x="314325" y="206905"/>
+            <a:ext cx="3943350" cy="751152"/>
           </a:xfrm>
           <a:prstGeom prst="rect">
             <a:avLst/>
@@ -2483,8 +2483,8 @@
         </p:nvSpPr>
         <p:spPr>
           <a:xfrm>
-            <a:off x="314325" y="973666"/>
-            <a:ext cx="3943350" cy="2320714"/>
+            <a:off x="314325" y="1034521"/>
+            <a:ext cx="3943350" cy="2465758"/>
           </a:xfrm>
           <a:prstGeom prst="rect">
             <a:avLst/>
@@ -2545,8 +2545,8 @@
         </p:nvSpPr>
         <p:spPr>
           <a:xfrm>
-            <a:off x="314325" y="3390054"/>
-            <a:ext cx="1028700" cy="194733"/>
+            <a:off x="314325" y="3601933"/>
+            <a:ext cx="1028700" cy="206904"/>
           </a:xfrm>
           <a:prstGeom prst="rect">
             <a:avLst/>
@@ -2568,7 +2568,7 @@
           <a:p>
             <a:fld id="{6640EBF9-9B9C-C849-9F58-C2602C067150}" type="datetimeFigureOut">
               <a:rPr lang="en-US" smtClean="0"/>
-              <a:t>6/1/26</a:t>
+              <a:t>7/2/26</a:t>
             </a:fld>
             <a:endParaRPr lang="en-US"/>
           </a:p>
@@ -2586,8 +2586,8 @@
         </p:nvSpPr>
         <p:spPr>
           <a:xfrm>
-            <a:off x="1514475" y="3390054"/>
-            <a:ext cx="1543050" cy="194733"/>
+            <a:off x="1514475" y="3601933"/>
+            <a:ext cx="1543050" cy="206904"/>
           </a:xfrm>
           <a:prstGeom prst="rect">
             <a:avLst/>
@@ -2623,8 +2623,8 @@
         </p:nvSpPr>
         <p:spPr>
           <a:xfrm>
-            <a:off x="3228975" y="3390054"/>
-            <a:ext cx="1028700" cy="194733"/>
+            <a:off x="3228975" y="3601933"/>
+            <a:ext cx="1028700" cy="206904"/>
           </a:xfrm>
           <a:prstGeom prst="rect">
             <a:avLst/>
@@ -2655,23 +2655,23 @@
     </p:spTree>
     <p:extLst>
       <p:ext uri="{BB962C8B-B14F-4D97-AF65-F5344CB8AC3E}">
-        <p14:creationId xmlns:p14="http://schemas.microsoft.com/office/powerpoint/2010/main" val="2796992147"/>
+        <p14:creationId xmlns:p14="http://schemas.microsoft.com/office/powerpoint/2010/main" val="229332530"/>
       </p:ext>
     </p:extLst>
   </p:cSld>
   <p:clrMap bg1="lt1" tx1="dk1" bg2="lt2" tx2="dk2" accent1="accent1" accent2="accent2" accent3="accent3" accent4="accent4" accent5="accent5" accent6="accent6" hlink="hlink" folHlink="folHlink"/>
   <p:sldLayoutIdLst>
-    <p:sldLayoutId id="2147483697" r:id="rId1"/>
-    <p:sldLayoutId id="2147483698" r:id="rId2"/>
-    <p:sldLayoutId id="2147483699" r:id="rId3"/>
-    <p:sldLayoutId id="2147483700" r:id="rId4"/>
-    <p:sldLayoutId id="2147483701" r:id="rId5"/>
-    <p:sldLayoutId id="2147483702" r:id="rId6"/>
-    <p:sldLayoutId id="2147483703" r:id="rId7"/>
-    <p:sldLayoutId id="2147483704" r:id="rId8"/>
-    <p:sldLayoutId id="2147483705" r:id="rId9"/>
-    <p:sldLayoutId id="2147483706" r:id="rId10"/>
-    <p:sldLayoutId id="2147483707" r:id="rId11"/>
+    <p:sldLayoutId id="2147483745" r:id="rId1"/>
+    <p:sldLayoutId id="2147483746" r:id="rId2"/>
+    <p:sldLayoutId id="2147483747" r:id="rId3"/>
+    <p:sldLayoutId id="2147483748" r:id="rId4"/>
+    <p:sldLayoutId id="2147483749" r:id="rId5"/>
+    <p:sldLayoutId id="2147483750" r:id="rId6"/>
+    <p:sldLayoutId id="2147483751" r:id="rId7"/>
+    <p:sldLayoutId id="2147483752" r:id="rId8"/>
+    <p:sldLayoutId id="2147483753" r:id="rId9"/>
+    <p:sldLayoutId id="2147483754" r:id="rId10"/>
+    <p:sldLayoutId id="2147483755" r:id="rId11"/>
   </p:sldLayoutIdLst>
   <p:txStyles>
     <p:titleStyle>
@@ -2987,7 +2987,7 @@
         </p:nvGrpSpPr>
         <p:grpSpPr>
           <a:xfrm>
-            <a:off x="182915" y="73062"/>
+            <a:off x="182416" y="68515"/>
             <a:ext cx="4206170" cy="1046958"/>
             <a:chOff x="450849" y="331081"/>
             <a:chExt cx="4206170" cy="1046958"/>
@@ -3330,7 +3330,19 @@
                   <a:rPr lang="en-US" sz="800" dirty="0">
                     <a:latin typeface="Helvetica" pitchFamily="2" charset="0"/>
                   </a:rPr>
-                  <a:t>Ancestor (A)</a:t>
+                  <a:t>Ancestor (</a:t>
+                </a:r>
+                <a:r>
+                  <a:rPr lang="en-US" sz="800" i="1" dirty="0">
+                    <a:latin typeface="Helvetica" pitchFamily="2" charset="0"/>
+                  </a:rPr>
+                  <a:t>A</a:t>
+                </a:r>
+                <a:r>
+                  <a:rPr lang="en-US" sz="800" dirty="0">
+                    <a:latin typeface="Helvetica" pitchFamily="2" charset="0"/>
+                  </a:rPr>
+                  <a:t>)</a:t>
                 </a:r>
               </a:p>
             </p:txBody>
@@ -3540,7 +3552,10 @@
                 </a:solidFill>
                 <a:ln w="25400">
                   <a:solidFill>
-                    <a:schemeClr val="accent4"/>
+                    <a:schemeClr val="tx1">
+                      <a:lumMod val="65000"/>
+                      <a:lumOff val="35000"/>
+                    </a:schemeClr>
                   </a:solidFill>
                 </a:ln>
               </p:spPr>
@@ -3592,7 +3607,7 @@
                   <a:avLst/>
                 </a:prstGeom>
                 <a:noFill/>
-                <a:ln w="25400">
+                <a:ln w="34925">
                   <a:solidFill>
                     <a:schemeClr val="accent4"/>
                   </a:solidFill>
@@ -3783,7 +3798,25 @@
                     </a:solidFill>
                     <a:latin typeface="Helvetica" pitchFamily="2" charset="0"/>
                   </a:rPr>
-                  <a:t>Plasmid-free (N)</a:t>
+                  <a:t>Plasmid-free (</a:t>
+                </a:r>
+                <a:r>
+                  <a:rPr lang="en-US" sz="800" i="1" dirty="0">
+                    <a:solidFill>
+                      <a:schemeClr val="tx1"/>
+                    </a:solidFill>
+                    <a:latin typeface="Helvetica" pitchFamily="2" charset="0"/>
+                  </a:rPr>
+                  <a:t>N</a:t>
+                </a:r>
+                <a:r>
+                  <a:rPr lang="en-US" sz="800" dirty="0">
+                    <a:solidFill>
+                      <a:schemeClr val="tx1"/>
+                    </a:solidFill>
+                    <a:latin typeface="Helvetica" pitchFamily="2" charset="0"/>
+                  </a:rPr>
+                  <a:t>)</a:t>
                 </a:r>
               </a:p>
             </p:txBody>
@@ -3811,7 +3844,9 @@
                 </a:avLst>
               </a:prstGeom>
               <a:solidFill>
-                <a:schemeClr val="bg2"/>
+                <a:schemeClr val="bg1">
+                  <a:lumMod val="85000"/>
+                </a:schemeClr>
               </a:solidFill>
               <a:ln w="25400">
                 <a:solidFill>
@@ -4160,7 +4195,19 @@
                   <a:rPr lang="en-US" sz="800" dirty="0">
                     <a:latin typeface="Helvetica" pitchFamily="2" charset="0"/>
                   </a:rPr>
-                  <a:t>Mutant (M)</a:t>
+                  <a:t>Mutant (</a:t>
+                </a:r>
+                <a:r>
+                  <a:rPr lang="en-US" sz="800" i="1" dirty="0">
+                    <a:latin typeface="Helvetica" pitchFamily="2" charset="0"/>
+                  </a:rPr>
+                  <a:t>M</a:t>
+                </a:r>
+                <a:r>
+                  <a:rPr lang="en-US" sz="800" dirty="0">
+                    <a:latin typeface="Helvetica" pitchFamily="2" charset="0"/>
+                  </a:rPr>
+                  <a:t>)</a:t>
                 </a:r>
               </a:p>
             </p:txBody>
@@ -4212,7 +4259,10 @@
                 </a:solidFill>
                 <a:ln w="25400">
                   <a:solidFill>
-                    <a:schemeClr val="accent5"/>
+                    <a:schemeClr val="tx1">
+                      <a:lumMod val="65000"/>
+                      <a:lumOff val="35000"/>
+                    </a:schemeClr>
                   </a:solidFill>
                 </a:ln>
               </p:spPr>
@@ -4264,7 +4314,7 @@
                   <a:avLst/>
                 </a:prstGeom>
                 <a:noFill/>
-                <a:ln w="25400">
+                <a:ln w="34925">
                   <a:solidFill>
                     <a:schemeClr val="accent5"/>
                   </a:solidFill>
@@ -4728,7 +4778,7 @@
         </p:nvSpPr>
         <p:spPr>
           <a:xfrm>
-            <a:off x="151909" y="38137"/>
+            <a:off x="151410" y="33592"/>
             <a:ext cx="287258" cy="276999"/>
           </a:xfrm>
           <a:prstGeom prst="rect">
@@ -4773,7 +4823,7 @@
         </p:blipFill>
         <p:spPr>
           <a:xfrm>
-            <a:off x="0" y="1143000"/>
+            <a:off x="-499" y="1370777"/>
             <a:ext cx="4572000" cy="2514600"/>
           </a:xfrm>
           <a:prstGeom prst="rect">
@@ -4781,6 +4831,2321 @@
           </a:prstGeom>
         </p:spPr>
       </p:pic>
+      <mc:AlternateContent xmlns:mc="http://schemas.openxmlformats.org/markup-compatibility/2006" xmlns:a14="http://schemas.microsoft.com/office/drawing/2010/main">
+        <mc:Choice Requires="a14">
+          <p:sp>
+            <p:nvSpPr>
+              <p:cNvPr id="2" name="TextBox 1">
+                <a:extLst>
+                  <a:ext uri="{FF2B5EF4-FFF2-40B4-BE49-F238E27FC236}">
+                    <a16:creationId xmlns:a16="http://schemas.microsoft.com/office/drawing/2014/main" id="{C05AB719-B60A-AAB7-C536-9FCD544F4402}"/>
+                  </a:ext>
+                </a:extLst>
+              </p:cNvPr>
+              <p:cNvSpPr txBox="1"/>
+              <p:nvPr/>
+            </p:nvSpPr>
+            <p:spPr>
+              <a:xfrm>
+                <a:off x="830000" y="1267687"/>
+                <a:ext cx="547971" cy="276999"/>
+              </a:xfrm>
+              <a:prstGeom prst="rect">
+                <a:avLst/>
+              </a:prstGeom>
+              <a:noFill/>
+            </p:spPr>
+            <p:txBody>
+              <a:bodyPr wrap="none" rtlCol="0">
+                <a:spAutoFit/>
+              </a:bodyPr>
+              <a:lstStyle/>
+              <a:p>
+                <a:pPr algn="ctr"/>
+                <a:r>
+                  <a:rPr lang="en-US" sz="1200" dirty="0">
+                    <a:latin typeface="Helvetica" pitchFamily="2" charset="0"/>
+                  </a:rPr>
+                  <a:t>low </a:t>
+                </a:r>
+                <a14:m>
+                  <m:oMath xmlns:m="http://schemas.openxmlformats.org/officeDocument/2006/math">
+                    <m:acc>
+                      <m:accPr>
+                        <m:chr m:val="̂"/>
+                        <m:ctrlPr>
+                          <a:rPr lang="en-US" sz="1200" i="1">
+                            <a:latin typeface="Cambria Math" panose="02040503050406030204" pitchFamily="18" charset="0"/>
+                          </a:rPr>
+                        </m:ctrlPr>
+                      </m:accPr>
+                      <m:e>
+                        <m:r>
+                          <a:rPr lang="en-US" sz="1200" i="1">
+                            <a:latin typeface="Cambria Math" panose="02040503050406030204" pitchFamily="18" charset="0"/>
+                          </a:rPr>
+                          <m:t>𝑛</m:t>
+                        </m:r>
+                      </m:e>
+                    </m:acc>
+                  </m:oMath>
+                </a14:m>
+                <a:endParaRPr lang="en-US" sz="1200" dirty="0">
+                  <a:latin typeface="Helvetica" pitchFamily="2" charset="0"/>
+                </a:endParaRPr>
+              </a:p>
+            </p:txBody>
+          </p:sp>
+        </mc:Choice>
+        <mc:Fallback xmlns="">
+          <p:sp>
+            <p:nvSpPr>
+              <p:cNvPr id="2" name="TextBox 1">
+                <a:extLst>
+                  <a:ext uri="{FF2B5EF4-FFF2-40B4-BE49-F238E27FC236}">
+                    <a16:creationId xmlns:a16="http://schemas.microsoft.com/office/drawing/2014/main" id="{C05AB719-B60A-AAB7-C536-9FCD544F4402}"/>
+                  </a:ext>
+                </a:extLst>
+              </p:cNvPr>
+              <p:cNvSpPr txBox="1">
+                <a:spLocks noRot="1" noChangeAspect="1" noMove="1" noResize="1" noEditPoints="1" noAdjustHandles="1" noChangeArrowheads="1" noChangeShapeType="1" noTextEdit="1"/>
+              </p:cNvSpPr>
+              <p:nvPr/>
+            </p:nvSpPr>
+            <p:spPr>
+              <a:xfrm>
+                <a:off x="830000" y="1267687"/>
+                <a:ext cx="547971" cy="276999"/>
+              </a:xfrm>
+              <a:prstGeom prst="rect">
+                <a:avLst/>
+              </a:prstGeom>
+              <a:blipFill>
+                <a:blip r:embed="rId3"/>
+                <a:stretch>
+                  <a:fillRect b="-13043"/>
+                </a:stretch>
+              </a:blipFill>
+            </p:spPr>
+            <p:txBody>
+              <a:bodyPr/>
+              <a:lstStyle/>
+              <a:p>
+                <a:r>
+                  <a:rPr lang="en-US">
+                    <a:noFill/>
+                  </a:rPr>
+                  <a:t> </a:t>
+                </a:r>
+              </a:p>
+            </p:txBody>
+          </p:sp>
+        </mc:Fallback>
+      </mc:AlternateContent>
+      <mc:AlternateContent xmlns:mc="http://schemas.openxmlformats.org/markup-compatibility/2006" xmlns:a14="http://schemas.microsoft.com/office/drawing/2010/main">
+        <mc:Choice Requires="a14">
+          <p:sp>
+            <p:nvSpPr>
+              <p:cNvPr id="4" name="TextBox 3">
+                <a:extLst>
+                  <a:ext uri="{FF2B5EF4-FFF2-40B4-BE49-F238E27FC236}">
+                    <a16:creationId xmlns:a16="http://schemas.microsoft.com/office/drawing/2014/main" id="{578E3C4C-B7F2-B09D-0952-DFDC269C185B}"/>
+                  </a:ext>
+                </a:extLst>
+              </p:cNvPr>
+              <p:cNvSpPr txBox="1"/>
+              <p:nvPr/>
+            </p:nvSpPr>
+            <p:spPr>
+              <a:xfrm>
+                <a:off x="2893040" y="1267687"/>
+                <a:ext cx="607282" cy="276999"/>
+              </a:xfrm>
+              <a:prstGeom prst="rect">
+                <a:avLst/>
+              </a:prstGeom>
+              <a:noFill/>
+            </p:spPr>
+            <p:txBody>
+              <a:bodyPr wrap="none" rtlCol="0">
+                <a:spAutoFit/>
+              </a:bodyPr>
+              <a:lstStyle/>
+              <a:p>
+                <a:pPr algn="ctr"/>
+                <a:r>
+                  <a:rPr lang="en-US" sz="1200" dirty="0">
+                    <a:latin typeface="Helvetica" pitchFamily="2" charset="0"/>
+                  </a:rPr>
+                  <a:t>high </a:t>
+                </a:r>
+                <a14:m>
+                  <m:oMath xmlns:m="http://schemas.openxmlformats.org/officeDocument/2006/math">
+                    <m:acc>
+                      <m:accPr>
+                        <m:chr m:val="̂"/>
+                        <m:ctrlPr>
+                          <a:rPr lang="en-US" sz="1200" i="1">
+                            <a:latin typeface="Cambria Math" panose="02040503050406030204" pitchFamily="18" charset="0"/>
+                          </a:rPr>
+                        </m:ctrlPr>
+                      </m:accPr>
+                      <m:e>
+                        <m:r>
+                          <a:rPr lang="en-US" sz="1200" i="1">
+                            <a:latin typeface="Cambria Math" panose="02040503050406030204" pitchFamily="18" charset="0"/>
+                          </a:rPr>
+                          <m:t>𝑛</m:t>
+                        </m:r>
+                      </m:e>
+                    </m:acc>
+                  </m:oMath>
+                </a14:m>
+                <a:endParaRPr lang="en-US" sz="1200" dirty="0">
+                  <a:latin typeface="Helvetica" pitchFamily="2" charset="0"/>
+                </a:endParaRPr>
+              </a:p>
+            </p:txBody>
+          </p:sp>
+        </mc:Choice>
+        <mc:Fallback xmlns="">
+          <p:sp>
+            <p:nvSpPr>
+              <p:cNvPr id="4" name="TextBox 3">
+                <a:extLst>
+                  <a:ext uri="{FF2B5EF4-FFF2-40B4-BE49-F238E27FC236}">
+                    <a16:creationId xmlns:a16="http://schemas.microsoft.com/office/drawing/2014/main" id="{578E3C4C-B7F2-B09D-0952-DFDC269C185B}"/>
+                  </a:ext>
+                </a:extLst>
+              </p:cNvPr>
+              <p:cNvSpPr txBox="1">
+                <a:spLocks noRot="1" noChangeAspect="1" noMove="1" noResize="1" noEditPoints="1" noAdjustHandles="1" noChangeArrowheads="1" noChangeShapeType="1" noTextEdit="1"/>
+              </p:cNvSpPr>
+              <p:nvPr/>
+            </p:nvSpPr>
+            <p:spPr>
+              <a:xfrm>
+                <a:off x="2893040" y="1267687"/>
+                <a:ext cx="607282" cy="276999"/>
+              </a:xfrm>
+              <a:prstGeom prst="rect">
+                <a:avLst/>
+              </a:prstGeom>
+              <a:blipFill>
+                <a:blip r:embed="rId4"/>
+                <a:stretch>
+                  <a:fillRect b="-13043"/>
+                </a:stretch>
+              </a:blipFill>
+            </p:spPr>
+            <p:txBody>
+              <a:bodyPr/>
+              <a:lstStyle/>
+              <a:p>
+                <a:r>
+                  <a:rPr lang="en-US">
+                    <a:noFill/>
+                  </a:rPr>
+                  <a:t> </a:t>
+                </a:r>
+              </a:p>
+            </p:txBody>
+          </p:sp>
+        </mc:Fallback>
+      </mc:AlternateContent>
+      <p:grpSp>
+        <p:nvGrpSpPr>
+          <p:cNvPr id="45" name="Group 44">
+            <a:extLst>
+              <a:ext uri="{FF2B5EF4-FFF2-40B4-BE49-F238E27FC236}">
+                <a16:creationId xmlns:a16="http://schemas.microsoft.com/office/drawing/2014/main" id="{166CB711-68CD-8117-50D9-8BE9175F487F}"/>
+              </a:ext>
+            </a:extLst>
+          </p:cNvPr>
+          <p:cNvGrpSpPr/>
+          <p:nvPr/>
+        </p:nvGrpSpPr>
+        <p:grpSpPr>
+          <a:xfrm>
+            <a:off x="3498366" y="1212414"/>
+            <a:ext cx="698772" cy="387544"/>
+            <a:chOff x="-553441" y="1259384"/>
+            <a:chExt cx="698772" cy="387544"/>
+          </a:xfrm>
+        </p:grpSpPr>
+        <p:sp>
+          <p:nvSpPr>
+            <p:cNvPr id="51" name="Rectangle 50">
+              <a:extLst>
+                <a:ext uri="{FF2B5EF4-FFF2-40B4-BE49-F238E27FC236}">
+                  <a16:creationId xmlns:a16="http://schemas.microsoft.com/office/drawing/2014/main" id="{BDC29218-83AF-05E3-A9B6-1B793ED2FD7D}"/>
+                </a:ext>
+              </a:extLst>
+            </p:cNvPr>
+            <p:cNvSpPr/>
+            <p:nvPr/>
+          </p:nvSpPr>
+          <p:spPr>
+            <a:xfrm>
+              <a:off x="-553441" y="1259384"/>
+              <a:ext cx="698772" cy="387544"/>
+            </a:xfrm>
+            <a:prstGeom prst="rect">
+              <a:avLst/>
+            </a:prstGeom>
+            <a:solidFill>
+              <a:schemeClr val="bg1"/>
+            </a:solidFill>
+            <a:ln w="9525">
+              <a:solidFill>
+                <a:schemeClr val="tx1">
+                  <a:lumMod val="65000"/>
+                  <a:lumOff val="35000"/>
+                </a:schemeClr>
+              </a:solidFill>
+            </a:ln>
+          </p:spPr>
+          <p:style>
+            <a:lnRef idx="2">
+              <a:schemeClr val="accent1">
+                <a:shade val="15000"/>
+              </a:schemeClr>
+            </a:lnRef>
+            <a:fillRef idx="1">
+              <a:schemeClr val="accent1"/>
+            </a:fillRef>
+            <a:effectRef idx="0">
+              <a:schemeClr val="accent1"/>
+            </a:effectRef>
+            <a:fontRef idx="minor">
+              <a:schemeClr val="lt1"/>
+            </a:fontRef>
+          </p:style>
+          <p:txBody>
+            <a:bodyPr rtlCol="0" anchor="ctr"/>
+            <a:lstStyle/>
+            <a:p>
+              <a:pPr algn="ctr"/>
+              <a:endParaRPr lang="en-US"/>
+            </a:p>
+          </p:txBody>
+        </p:sp>
+        <p:sp>
+          <p:nvSpPr>
+            <p:cNvPr id="52" name="Rounded Rectangle 51">
+              <a:extLst>
+                <a:ext uri="{FF2B5EF4-FFF2-40B4-BE49-F238E27FC236}">
+                  <a16:creationId xmlns:a16="http://schemas.microsoft.com/office/drawing/2014/main" id="{10285A1E-845E-013D-B895-395E95B43E42}"/>
+                </a:ext>
+              </a:extLst>
+            </p:cNvPr>
+            <p:cNvSpPr/>
+            <p:nvPr/>
+          </p:nvSpPr>
+          <p:spPr>
+            <a:xfrm rot="20083086">
+              <a:off x="-525224" y="1317983"/>
+              <a:ext cx="154288" cy="91263"/>
+            </a:xfrm>
+            <a:prstGeom prst="roundRect">
+              <a:avLst>
+                <a:gd name="adj" fmla="val 47948"/>
+              </a:avLst>
+            </a:prstGeom>
+            <a:solidFill>
+              <a:schemeClr val="bg1">
+                <a:lumMod val="85000"/>
+              </a:schemeClr>
+            </a:solidFill>
+            <a:ln w="9525">
+              <a:solidFill>
+                <a:schemeClr val="tx1">
+                  <a:lumMod val="65000"/>
+                  <a:lumOff val="35000"/>
+                </a:schemeClr>
+              </a:solidFill>
+            </a:ln>
+          </p:spPr>
+          <p:style>
+            <a:lnRef idx="2">
+              <a:schemeClr val="accent1">
+                <a:shade val="15000"/>
+              </a:schemeClr>
+            </a:lnRef>
+            <a:fillRef idx="1">
+              <a:schemeClr val="accent1"/>
+            </a:fillRef>
+            <a:effectRef idx="0">
+              <a:schemeClr val="accent1"/>
+            </a:effectRef>
+            <a:fontRef idx="minor">
+              <a:schemeClr val="lt1"/>
+            </a:fontRef>
+          </p:style>
+          <p:txBody>
+            <a:bodyPr rtlCol="0" anchor="ctr"/>
+            <a:lstStyle/>
+            <a:p>
+              <a:pPr algn="ctr"/>
+              <a:endParaRPr lang="en-US" sz="800" dirty="0">
+                <a:latin typeface="Helvetica" pitchFamily="2" charset="0"/>
+              </a:endParaRPr>
+            </a:p>
+          </p:txBody>
+        </p:sp>
+        <p:grpSp>
+          <p:nvGrpSpPr>
+            <p:cNvPr id="53" name="Group 52">
+              <a:extLst>
+                <a:ext uri="{FF2B5EF4-FFF2-40B4-BE49-F238E27FC236}">
+                  <a16:creationId xmlns:a16="http://schemas.microsoft.com/office/drawing/2014/main" id="{C13CC9DC-0680-1311-5820-25C2EE970BC2}"/>
+                </a:ext>
+              </a:extLst>
+            </p:cNvPr>
+            <p:cNvGrpSpPr/>
+            <p:nvPr/>
+          </p:nvGrpSpPr>
+          <p:grpSpPr>
+            <a:xfrm rot="20042611">
+              <a:off x="-534672" y="1510090"/>
+              <a:ext cx="154288" cy="91263"/>
+              <a:chOff x="6979" y="1284864"/>
+              <a:chExt cx="588779" cy="348270"/>
+            </a:xfrm>
+          </p:grpSpPr>
+          <p:sp>
+            <p:nvSpPr>
+              <p:cNvPr id="87" name="Rounded Rectangle 86">
+                <a:extLst>
+                  <a:ext uri="{FF2B5EF4-FFF2-40B4-BE49-F238E27FC236}">
+                    <a16:creationId xmlns:a16="http://schemas.microsoft.com/office/drawing/2014/main" id="{3DE80AEF-7953-BA58-23D4-17FF3952E28B}"/>
+                  </a:ext>
+                </a:extLst>
+              </p:cNvPr>
+              <p:cNvSpPr/>
+              <p:nvPr/>
+            </p:nvSpPr>
+            <p:spPr>
+              <a:xfrm>
+                <a:off x="6979" y="1284864"/>
+                <a:ext cx="588779" cy="348270"/>
+              </a:xfrm>
+              <a:prstGeom prst="roundRect">
+                <a:avLst>
+                  <a:gd name="adj" fmla="val 47948"/>
+                </a:avLst>
+              </a:prstGeom>
+              <a:solidFill>
+                <a:schemeClr val="bg1"/>
+              </a:solidFill>
+              <a:ln w="9525">
+                <a:solidFill>
+                  <a:schemeClr val="tx1">
+                    <a:lumMod val="65000"/>
+                    <a:lumOff val="35000"/>
+                  </a:schemeClr>
+                </a:solidFill>
+              </a:ln>
+            </p:spPr>
+            <p:style>
+              <a:lnRef idx="2">
+                <a:schemeClr val="accent1">
+                  <a:shade val="15000"/>
+                </a:schemeClr>
+              </a:lnRef>
+              <a:fillRef idx="1">
+                <a:schemeClr val="accent1"/>
+              </a:fillRef>
+              <a:effectRef idx="0">
+                <a:schemeClr val="accent1"/>
+              </a:effectRef>
+              <a:fontRef idx="minor">
+                <a:schemeClr val="lt1"/>
+              </a:fontRef>
+            </p:style>
+            <p:txBody>
+              <a:bodyPr rtlCol="0" anchor="ctr"/>
+              <a:lstStyle/>
+              <a:p>
+                <a:pPr algn="ctr"/>
+                <a:endParaRPr lang="en-US" sz="800" dirty="0">
+                  <a:latin typeface="Helvetica" pitchFamily="2" charset="0"/>
+                </a:endParaRPr>
+              </a:p>
+            </p:txBody>
+          </p:sp>
+          <p:sp>
+            <p:nvSpPr>
+              <p:cNvPr id="88" name="Oval 87">
+                <a:extLst>
+                  <a:ext uri="{FF2B5EF4-FFF2-40B4-BE49-F238E27FC236}">
+                    <a16:creationId xmlns:a16="http://schemas.microsoft.com/office/drawing/2014/main" id="{212A12CB-A15E-1FED-5170-3BB307905792}"/>
+                  </a:ext>
+                </a:extLst>
+              </p:cNvPr>
+              <p:cNvSpPr/>
+              <p:nvPr/>
+            </p:nvSpPr>
+            <p:spPr>
+              <a:xfrm>
+                <a:off x="319623" y="1364860"/>
+                <a:ext cx="199597" cy="199594"/>
+              </a:xfrm>
+              <a:prstGeom prst="ellipse">
+                <a:avLst/>
+              </a:prstGeom>
+              <a:noFill/>
+              <a:ln w="12700">
+                <a:solidFill>
+                  <a:schemeClr val="accent4"/>
+                </a:solidFill>
+              </a:ln>
+            </p:spPr>
+            <p:style>
+              <a:lnRef idx="2">
+                <a:schemeClr val="accent1">
+                  <a:shade val="15000"/>
+                </a:schemeClr>
+              </a:lnRef>
+              <a:fillRef idx="1">
+                <a:schemeClr val="accent1"/>
+              </a:fillRef>
+              <a:effectRef idx="0">
+                <a:schemeClr val="accent1"/>
+              </a:effectRef>
+              <a:fontRef idx="minor">
+                <a:schemeClr val="lt1"/>
+              </a:fontRef>
+            </p:style>
+            <p:txBody>
+              <a:bodyPr rtlCol="0" anchor="ctr"/>
+              <a:lstStyle/>
+              <a:p>
+                <a:pPr algn="ctr"/>
+                <a:endParaRPr lang="en-US" sz="800">
+                  <a:latin typeface="Helvetica" pitchFamily="2" charset="0"/>
+                </a:endParaRPr>
+              </a:p>
+            </p:txBody>
+          </p:sp>
+        </p:grpSp>
+        <p:sp>
+          <p:nvSpPr>
+            <p:cNvPr id="85" name="Rounded Rectangle 84">
+              <a:extLst>
+                <a:ext uri="{FF2B5EF4-FFF2-40B4-BE49-F238E27FC236}">
+                  <a16:creationId xmlns:a16="http://schemas.microsoft.com/office/drawing/2014/main" id="{8F6B5A33-09C7-86E1-F09D-C3C4DACC538D}"/>
+                </a:ext>
+              </a:extLst>
+            </p:cNvPr>
+            <p:cNvSpPr/>
+            <p:nvPr/>
+          </p:nvSpPr>
+          <p:spPr>
+            <a:xfrm rot="488309">
+              <a:off x="-401566" y="1408102"/>
+              <a:ext cx="154288" cy="91263"/>
+            </a:xfrm>
+            <a:prstGeom prst="roundRect">
+              <a:avLst>
+                <a:gd name="adj" fmla="val 47948"/>
+              </a:avLst>
+            </a:prstGeom>
+            <a:solidFill>
+              <a:schemeClr val="bg1">
+                <a:lumMod val="85000"/>
+              </a:schemeClr>
+            </a:solidFill>
+            <a:ln w="9525">
+              <a:solidFill>
+                <a:schemeClr val="tx1">
+                  <a:lumMod val="65000"/>
+                  <a:lumOff val="35000"/>
+                </a:schemeClr>
+              </a:solidFill>
+            </a:ln>
+          </p:spPr>
+          <p:style>
+            <a:lnRef idx="2">
+              <a:schemeClr val="accent1">
+                <a:shade val="15000"/>
+              </a:schemeClr>
+            </a:lnRef>
+            <a:fillRef idx="1">
+              <a:schemeClr val="accent1"/>
+            </a:fillRef>
+            <a:effectRef idx="0">
+              <a:schemeClr val="accent1"/>
+            </a:effectRef>
+            <a:fontRef idx="minor">
+              <a:schemeClr val="lt1"/>
+            </a:fontRef>
+          </p:style>
+          <p:txBody>
+            <a:bodyPr rtlCol="0" anchor="ctr"/>
+            <a:lstStyle/>
+            <a:p>
+              <a:pPr algn="ctr"/>
+              <a:endParaRPr lang="en-US" sz="800" dirty="0">
+                <a:latin typeface="Helvetica" pitchFamily="2" charset="0"/>
+              </a:endParaRPr>
+            </a:p>
+          </p:txBody>
+        </p:sp>
+        <p:grpSp>
+          <p:nvGrpSpPr>
+            <p:cNvPr id="55" name="Group 54">
+              <a:extLst>
+                <a:ext uri="{FF2B5EF4-FFF2-40B4-BE49-F238E27FC236}">
+                  <a16:creationId xmlns:a16="http://schemas.microsoft.com/office/drawing/2014/main" id="{1F563737-48EC-9685-CEED-D67D7795F319}"/>
+                </a:ext>
+              </a:extLst>
+            </p:cNvPr>
+            <p:cNvGrpSpPr/>
+            <p:nvPr/>
+          </p:nvGrpSpPr>
+          <p:grpSpPr>
+            <a:xfrm>
+              <a:off x="-333360" y="1525725"/>
+              <a:ext cx="154288" cy="91263"/>
+              <a:chOff x="6979" y="1284864"/>
+              <a:chExt cx="588779" cy="348270"/>
+            </a:xfrm>
+          </p:grpSpPr>
+          <p:sp>
+            <p:nvSpPr>
+              <p:cNvPr id="83" name="Rounded Rectangle 82">
+                <a:extLst>
+                  <a:ext uri="{FF2B5EF4-FFF2-40B4-BE49-F238E27FC236}">
+                    <a16:creationId xmlns:a16="http://schemas.microsoft.com/office/drawing/2014/main" id="{FAA9E681-733C-14FF-01E6-7236D51D677E}"/>
+                  </a:ext>
+                </a:extLst>
+              </p:cNvPr>
+              <p:cNvSpPr/>
+              <p:nvPr/>
+            </p:nvSpPr>
+            <p:spPr>
+              <a:xfrm>
+                <a:off x="6979" y="1284864"/>
+                <a:ext cx="588779" cy="348270"/>
+              </a:xfrm>
+              <a:prstGeom prst="roundRect">
+                <a:avLst>
+                  <a:gd name="adj" fmla="val 47948"/>
+                </a:avLst>
+              </a:prstGeom>
+              <a:solidFill>
+                <a:schemeClr val="bg1"/>
+              </a:solidFill>
+              <a:ln w="9525">
+                <a:solidFill>
+                  <a:schemeClr val="tx1">
+                    <a:lumMod val="65000"/>
+                    <a:lumOff val="35000"/>
+                  </a:schemeClr>
+                </a:solidFill>
+              </a:ln>
+            </p:spPr>
+            <p:style>
+              <a:lnRef idx="2">
+                <a:schemeClr val="accent1">
+                  <a:shade val="15000"/>
+                </a:schemeClr>
+              </a:lnRef>
+              <a:fillRef idx="1">
+                <a:schemeClr val="accent1"/>
+              </a:fillRef>
+              <a:effectRef idx="0">
+                <a:schemeClr val="accent1"/>
+              </a:effectRef>
+              <a:fontRef idx="minor">
+                <a:schemeClr val="lt1"/>
+              </a:fontRef>
+            </p:style>
+            <p:txBody>
+              <a:bodyPr rtlCol="0" anchor="ctr"/>
+              <a:lstStyle/>
+              <a:p>
+                <a:pPr algn="ctr"/>
+                <a:endParaRPr lang="en-US" sz="800" dirty="0">
+                  <a:latin typeface="Helvetica" pitchFamily="2" charset="0"/>
+                </a:endParaRPr>
+              </a:p>
+            </p:txBody>
+          </p:sp>
+          <p:sp>
+            <p:nvSpPr>
+              <p:cNvPr id="84" name="Oval 83">
+                <a:extLst>
+                  <a:ext uri="{FF2B5EF4-FFF2-40B4-BE49-F238E27FC236}">
+                    <a16:creationId xmlns:a16="http://schemas.microsoft.com/office/drawing/2014/main" id="{37B9C5F7-1F73-0CEE-8709-F110E61FBA38}"/>
+                  </a:ext>
+                </a:extLst>
+              </p:cNvPr>
+              <p:cNvSpPr/>
+              <p:nvPr/>
+            </p:nvSpPr>
+            <p:spPr>
+              <a:xfrm>
+                <a:off x="325300" y="1353198"/>
+                <a:ext cx="199597" cy="199596"/>
+              </a:xfrm>
+              <a:prstGeom prst="ellipse">
+                <a:avLst/>
+              </a:prstGeom>
+              <a:noFill/>
+              <a:ln w="12700">
+                <a:solidFill>
+                  <a:schemeClr val="accent4"/>
+                </a:solidFill>
+              </a:ln>
+            </p:spPr>
+            <p:style>
+              <a:lnRef idx="2">
+                <a:schemeClr val="accent1">
+                  <a:shade val="15000"/>
+                </a:schemeClr>
+              </a:lnRef>
+              <a:fillRef idx="1">
+                <a:schemeClr val="accent1"/>
+              </a:fillRef>
+              <a:effectRef idx="0">
+                <a:schemeClr val="accent1"/>
+              </a:effectRef>
+              <a:fontRef idx="minor">
+                <a:schemeClr val="lt1"/>
+              </a:fontRef>
+            </p:style>
+            <p:txBody>
+              <a:bodyPr rtlCol="0" anchor="ctr"/>
+              <a:lstStyle/>
+              <a:p>
+                <a:pPr algn="ctr"/>
+                <a:endParaRPr lang="en-US" sz="800">
+                  <a:latin typeface="Helvetica" pitchFamily="2" charset="0"/>
+                </a:endParaRPr>
+              </a:p>
+            </p:txBody>
+          </p:sp>
+        </p:grpSp>
+        <p:sp>
+          <p:nvSpPr>
+            <p:cNvPr id="56" name="Rounded Rectangle 55">
+              <a:extLst>
+                <a:ext uri="{FF2B5EF4-FFF2-40B4-BE49-F238E27FC236}">
+                  <a16:creationId xmlns:a16="http://schemas.microsoft.com/office/drawing/2014/main" id="{E2C13891-FBBB-35E2-774E-EC3D93DC48CF}"/>
+                </a:ext>
+              </a:extLst>
+            </p:cNvPr>
+            <p:cNvSpPr/>
+            <p:nvPr/>
+          </p:nvSpPr>
+          <p:spPr>
+            <a:xfrm rot="20083086">
+              <a:off x="-206809" y="1378937"/>
+              <a:ext cx="154288" cy="91263"/>
+            </a:xfrm>
+            <a:prstGeom prst="roundRect">
+              <a:avLst>
+                <a:gd name="adj" fmla="val 47948"/>
+              </a:avLst>
+            </a:prstGeom>
+            <a:solidFill>
+              <a:schemeClr val="bg1">
+                <a:lumMod val="85000"/>
+              </a:schemeClr>
+            </a:solidFill>
+            <a:ln w="9525">
+              <a:solidFill>
+                <a:schemeClr val="tx1">
+                  <a:lumMod val="65000"/>
+                  <a:lumOff val="35000"/>
+                </a:schemeClr>
+              </a:solidFill>
+            </a:ln>
+          </p:spPr>
+          <p:style>
+            <a:lnRef idx="2">
+              <a:schemeClr val="accent1">
+                <a:shade val="15000"/>
+              </a:schemeClr>
+            </a:lnRef>
+            <a:fillRef idx="1">
+              <a:schemeClr val="accent1"/>
+            </a:fillRef>
+            <a:effectRef idx="0">
+              <a:schemeClr val="accent1"/>
+            </a:effectRef>
+            <a:fontRef idx="minor">
+              <a:schemeClr val="lt1"/>
+            </a:fontRef>
+          </p:style>
+          <p:txBody>
+            <a:bodyPr rtlCol="0" anchor="ctr"/>
+            <a:lstStyle/>
+            <a:p>
+              <a:pPr algn="ctr"/>
+              <a:endParaRPr lang="en-US" sz="800" dirty="0">
+                <a:latin typeface="Helvetica" pitchFamily="2" charset="0"/>
+              </a:endParaRPr>
+            </a:p>
+          </p:txBody>
+        </p:sp>
+        <p:sp>
+          <p:nvSpPr>
+            <p:cNvPr id="81" name="Rounded Rectangle 80">
+              <a:extLst>
+                <a:ext uri="{FF2B5EF4-FFF2-40B4-BE49-F238E27FC236}">
+                  <a16:creationId xmlns:a16="http://schemas.microsoft.com/office/drawing/2014/main" id="{A3574370-A28E-ECA9-F8E5-83E60F6E123D}"/>
+                </a:ext>
+              </a:extLst>
+            </p:cNvPr>
+            <p:cNvSpPr/>
+            <p:nvPr/>
+          </p:nvSpPr>
+          <p:spPr>
+            <a:xfrm rot="488309">
+              <a:off x="-148212" y="1522195"/>
+              <a:ext cx="154288" cy="91263"/>
+            </a:xfrm>
+            <a:prstGeom prst="roundRect">
+              <a:avLst>
+                <a:gd name="adj" fmla="val 47948"/>
+              </a:avLst>
+            </a:prstGeom>
+            <a:solidFill>
+              <a:schemeClr val="bg1">
+                <a:lumMod val="85000"/>
+              </a:schemeClr>
+            </a:solidFill>
+            <a:ln w="9525">
+              <a:solidFill>
+                <a:schemeClr val="tx1">
+                  <a:lumMod val="65000"/>
+                  <a:lumOff val="35000"/>
+                </a:schemeClr>
+              </a:solidFill>
+            </a:ln>
+          </p:spPr>
+          <p:style>
+            <a:lnRef idx="2">
+              <a:schemeClr val="accent1">
+                <a:shade val="15000"/>
+              </a:schemeClr>
+            </a:lnRef>
+            <a:fillRef idx="1">
+              <a:schemeClr val="accent1"/>
+            </a:fillRef>
+            <a:effectRef idx="0">
+              <a:schemeClr val="accent1"/>
+            </a:effectRef>
+            <a:fontRef idx="minor">
+              <a:schemeClr val="lt1"/>
+            </a:fontRef>
+          </p:style>
+          <p:txBody>
+            <a:bodyPr rtlCol="0" anchor="ctr"/>
+            <a:lstStyle/>
+            <a:p>
+              <a:pPr algn="ctr"/>
+              <a:endParaRPr lang="en-US" sz="800" dirty="0">
+                <a:latin typeface="Helvetica" pitchFamily="2" charset="0"/>
+              </a:endParaRPr>
+            </a:p>
+          </p:txBody>
+        </p:sp>
+        <p:grpSp>
+          <p:nvGrpSpPr>
+            <p:cNvPr id="58" name="Group 57">
+              <a:extLst>
+                <a:ext uri="{FF2B5EF4-FFF2-40B4-BE49-F238E27FC236}">
+                  <a16:creationId xmlns:a16="http://schemas.microsoft.com/office/drawing/2014/main" id="{57F9FB65-12C9-59E3-E3DF-13EA5445CB22}"/>
+                </a:ext>
+              </a:extLst>
+            </p:cNvPr>
+            <p:cNvGrpSpPr/>
+            <p:nvPr/>
+          </p:nvGrpSpPr>
+          <p:grpSpPr>
+            <a:xfrm rot="1532720">
+              <a:off x="-66495" y="1296574"/>
+              <a:ext cx="154288" cy="91263"/>
+              <a:chOff x="6979" y="1284864"/>
+              <a:chExt cx="588779" cy="348270"/>
+            </a:xfrm>
+          </p:grpSpPr>
+          <p:sp>
+            <p:nvSpPr>
+              <p:cNvPr id="79" name="Rounded Rectangle 78">
+                <a:extLst>
+                  <a:ext uri="{FF2B5EF4-FFF2-40B4-BE49-F238E27FC236}">
+                    <a16:creationId xmlns:a16="http://schemas.microsoft.com/office/drawing/2014/main" id="{E66C8804-3D72-12CE-764F-ED83BE11C45E}"/>
+                  </a:ext>
+                </a:extLst>
+              </p:cNvPr>
+              <p:cNvSpPr/>
+              <p:nvPr/>
+            </p:nvSpPr>
+            <p:spPr>
+              <a:xfrm>
+                <a:off x="6979" y="1284864"/>
+                <a:ext cx="588779" cy="348270"/>
+              </a:xfrm>
+              <a:prstGeom prst="roundRect">
+                <a:avLst>
+                  <a:gd name="adj" fmla="val 47948"/>
+                </a:avLst>
+              </a:prstGeom>
+              <a:solidFill>
+                <a:schemeClr val="bg1"/>
+              </a:solidFill>
+              <a:ln w="9525">
+                <a:solidFill>
+                  <a:schemeClr val="tx1">
+                    <a:lumMod val="65000"/>
+                    <a:lumOff val="35000"/>
+                  </a:schemeClr>
+                </a:solidFill>
+              </a:ln>
+            </p:spPr>
+            <p:style>
+              <a:lnRef idx="2">
+                <a:schemeClr val="accent1">
+                  <a:shade val="15000"/>
+                </a:schemeClr>
+              </a:lnRef>
+              <a:fillRef idx="1">
+                <a:schemeClr val="accent1"/>
+              </a:fillRef>
+              <a:effectRef idx="0">
+                <a:schemeClr val="accent1"/>
+              </a:effectRef>
+              <a:fontRef idx="minor">
+                <a:schemeClr val="lt1"/>
+              </a:fontRef>
+            </p:style>
+            <p:txBody>
+              <a:bodyPr rtlCol="0" anchor="ctr"/>
+              <a:lstStyle/>
+              <a:p>
+                <a:pPr algn="ctr"/>
+                <a:endParaRPr lang="en-US" sz="800" dirty="0">
+                  <a:latin typeface="Helvetica" pitchFamily="2" charset="0"/>
+                </a:endParaRPr>
+              </a:p>
+            </p:txBody>
+          </p:sp>
+          <p:sp>
+            <p:nvSpPr>
+              <p:cNvPr id="80" name="Oval 79">
+                <a:extLst>
+                  <a:ext uri="{FF2B5EF4-FFF2-40B4-BE49-F238E27FC236}">
+                    <a16:creationId xmlns:a16="http://schemas.microsoft.com/office/drawing/2014/main" id="{EE79ECCD-DBDF-2AA5-5B32-410420933A86}"/>
+                  </a:ext>
+                </a:extLst>
+              </p:cNvPr>
+              <p:cNvSpPr/>
+              <p:nvPr/>
+            </p:nvSpPr>
+            <p:spPr>
+              <a:xfrm>
+                <a:off x="325300" y="1353198"/>
+                <a:ext cx="199597" cy="199596"/>
+              </a:xfrm>
+              <a:prstGeom prst="ellipse">
+                <a:avLst/>
+              </a:prstGeom>
+              <a:noFill/>
+              <a:ln w="12700">
+                <a:solidFill>
+                  <a:schemeClr val="accent4"/>
+                </a:solidFill>
+              </a:ln>
+            </p:spPr>
+            <p:style>
+              <a:lnRef idx="2">
+                <a:schemeClr val="accent1">
+                  <a:shade val="15000"/>
+                </a:schemeClr>
+              </a:lnRef>
+              <a:fillRef idx="1">
+                <a:schemeClr val="accent1"/>
+              </a:fillRef>
+              <a:effectRef idx="0">
+                <a:schemeClr val="accent1"/>
+              </a:effectRef>
+              <a:fontRef idx="minor">
+                <a:schemeClr val="lt1"/>
+              </a:fontRef>
+            </p:style>
+            <p:txBody>
+              <a:bodyPr rtlCol="0" anchor="ctr"/>
+              <a:lstStyle/>
+              <a:p>
+                <a:pPr algn="ctr"/>
+                <a:endParaRPr lang="en-US" sz="800">
+                  <a:latin typeface="Helvetica" pitchFamily="2" charset="0"/>
+                </a:endParaRPr>
+              </a:p>
+            </p:txBody>
+          </p:sp>
+        </p:grpSp>
+        <p:sp>
+          <p:nvSpPr>
+            <p:cNvPr id="59" name="Rounded Rectangle 58">
+              <a:extLst>
+                <a:ext uri="{FF2B5EF4-FFF2-40B4-BE49-F238E27FC236}">
+                  <a16:creationId xmlns:a16="http://schemas.microsoft.com/office/drawing/2014/main" id="{130F2CBE-5AA0-8506-9164-CAC5A88DC084}"/>
+                </a:ext>
+              </a:extLst>
+            </p:cNvPr>
+            <p:cNvSpPr/>
+            <p:nvPr/>
+          </p:nvSpPr>
+          <p:spPr>
+            <a:xfrm>
+              <a:off x="-339873" y="1290171"/>
+              <a:ext cx="154288" cy="91263"/>
+            </a:xfrm>
+            <a:prstGeom prst="roundRect">
+              <a:avLst>
+                <a:gd name="adj" fmla="val 47948"/>
+              </a:avLst>
+            </a:prstGeom>
+            <a:solidFill>
+              <a:schemeClr val="bg1">
+                <a:lumMod val="85000"/>
+              </a:schemeClr>
+            </a:solidFill>
+            <a:ln w="9525">
+              <a:solidFill>
+                <a:schemeClr val="tx1">
+                  <a:lumMod val="65000"/>
+                  <a:lumOff val="35000"/>
+                </a:schemeClr>
+              </a:solidFill>
+            </a:ln>
+          </p:spPr>
+          <p:style>
+            <a:lnRef idx="2">
+              <a:schemeClr val="accent1">
+                <a:shade val="15000"/>
+              </a:schemeClr>
+            </a:lnRef>
+            <a:fillRef idx="1">
+              <a:schemeClr val="accent1"/>
+            </a:fillRef>
+            <a:effectRef idx="0">
+              <a:schemeClr val="accent1"/>
+            </a:effectRef>
+            <a:fontRef idx="minor">
+              <a:schemeClr val="lt1"/>
+            </a:fontRef>
+          </p:style>
+          <p:txBody>
+            <a:bodyPr rtlCol="0" anchor="ctr"/>
+            <a:lstStyle/>
+            <a:p>
+              <a:pPr algn="ctr"/>
+              <a:endParaRPr lang="en-US" sz="800" dirty="0">
+                <a:latin typeface="Helvetica" pitchFamily="2" charset="0"/>
+              </a:endParaRPr>
+            </a:p>
+          </p:txBody>
+        </p:sp>
+        <p:grpSp>
+          <p:nvGrpSpPr>
+            <p:cNvPr id="69" name="Group 68">
+              <a:extLst>
+                <a:ext uri="{FF2B5EF4-FFF2-40B4-BE49-F238E27FC236}">
+                  <a16:creationId xmlns:a16="http://schemas.microsoft.com/office/drawing/2014/main" id="{1D3C1952-F680-6844-A7D8-811106864F08}"/>
+                </a:ext>
+              </a:extLst>
+            </p:cNvPr>
+            <p:cNvGrpSpPr/>
+            <p:nvPr/>
+          </p:nvGrpSpPr>
+          <p:grpSpPr>
+            <a:xfrm rot="13005164">
+              <a:off x="-23210" y="1449929"/>
+              <a:ext cx="154288" cy="91263"/>
+              <a:chOff x="6979" y="1284864"/>
+              <a:chExt cx="588779" cy="348270"/>
+            </a:xfrm>
+          </p:grpSpPr>
+          <p:sp>
+            <p:nvSpPr>
+              <p:cNvPr id="70" name="Rounded Rectangle 69">
+                <a:extLst>
+                  <a:ext uri="{FF2B5EF4-FFF2-40B4-BE49-F238E27FC236}">
+                    <a16:creationId xmlns:a16="http://schemas.microsoft.com/office/drawing/2014/main" id="{0C5C5979-8E36-87BF-BDE2-3D81314FBB24}"/>
+                  </a:ext>
+                </a:extLst>
+              </p:cNvPr>
+              <p:cNvSpPr/>
+              <p:nvPr/>
+            </p:nvSpPr>
+            <p:spPr>
+              <a:xfrm>
+                <a:off x="6979" y="1284864"/>
+                <a:ext cx="588779" cy="348270"/>
+              </a:xfrm>
+              <a:prstGeom prst="roundRect">
+                <a:avLst>
+                  <a:gd name="adj" fmla="val 47948"/>
+                </a:avLst>
+              </a:prstGeom>
+              <a:solidFill>
+                <a:schemeClr val="bg1"/>
+              </a:solidFill>
+              <a:ln w="9525">
+                <a:solidFill>
+                  <a:schemeClr val="tx1">
+                    <a:lumMod val="65000"/>
+                    <a:lumOff val="35000"/>
+                  </a:schemeClr>
+                </a:solidFill>
+              </a:ln>
+            </p:spPr>
+            <p:style>
+              <a:lnRef idx="2">
+                <a:schemeClr val="accent1">
+                  <a:shade val="15000"/>
+                </a:schemeClr>
+              </a:lnRef>
+              <a:fillRef idx="1">
+                <a:schemeClr val="accent1"/>
+              </a:fillRef>
+              <a:effectRef idx="0">
+                <a:schemeClr val="accent1"/>
+              </a:effectRef>
+              <a:fontRef idx="minor">
+                <a:schemeClr val="lt1"/>
+              </a:fontRef>
+            </p:style>
+            <p:txBody>
+              <a:bodyPr rtlCol="0" anchor="ctr"/>
+              <a:lstStyle/>
+              <a:p>
+                <a:pPr algn="ctr"/>
+                <a:endParaRPr lang="en-US" sz="800" dirty="0">
+                  <a:latin typeface="Helvetica" pitchFamily="2" charset="0"/>
+                </a:endParaRPr>
+              </a:p>
+            </p:txBody>
+          </p:sp>
+          <p:sp>
+            <p:nvSpPr>
+              <p:cNvPr id="76" name="Oval 75">
+                <a:extLst>
+                  <a:ext uri="{FF2B5EF4-FFF2-40B4-BE49-F238E27FC236}">
+                    <a16:creationId xmlns:a16="http://schemas.microsoft.com/office/drawing/2014/main" id="{5B17CD7C-C7F3-FD86-0245-0D3102D13007}"/>
+                  </a:ext>
+                </a:extLst>
+              </p:cNvPr>
+              <p:cNvSpPr/>
+              <p:nvPr/>
+            </p:nvSpPr>
+            <p:spPr>
+              <a:xfrm>
+                <a:off x="325300" y="1353198"/>
+                <a:ext cx="199597" cy="199596"/>
+              </a:xfrm>
+              <a:prstGeom prst="ellipse">
+                <a:avLst/>
+              </a:prstGeom>
+              <a:noFill/>
+              <a:ln w="12700">
+                <a:solidFill>
+                  <a:schemeClr val="accent4"/>
+                </a:solidFill>
+              </a:ln>
+            </p:spPr>
+            <p:style>
+              <a:lnRef idx="2">
+                <a:schemeClr val="accent1">
+                  <a:shade val="15000"/>
+                </a:schemeClr>
+              </a:lnRef>
+              <a:fillRef idx="1">
+                <a:schemeClr val="accent1"/>
+              </a:fillRef>
+              <a:effectRef idx="0">
+                <a:schemeClr val="accent1"/>
+              </a:effectRef>
+              <a:fontRef idx="minor">
+                <a:schemeClr val="lt1"/>
+              </a:fontRef>
+            </p:style>
+            <p:txBody>
+              <a:bodyPr rtlCol="0" anchor="ctr"/>
+              <a:lstStyle/>
+              <a:p>
+                <a:pPr algn="ctr"/>
+                <a:endParaRPr lang="en-US" sz="800">
+                  <a:latin typeface="Helvetica" pitchFamily="2" charset="0"/>
+                </a:endParaRPr>
+              </a:p>
+            </p:txBody>
+          </p:sp>
+        </p:grpSp>
+      </p:grpSp>
+      <p:grpSp>
+        <p:nvGrpSpPr>
+          <p:cNvPr id="90" name="Group 89">
+            <a:extLst>
+              <a:ext uri="{FF2B5EF4-FFF2-40B4-BE49-F238E27FC236}">
+                <a16:creationId xmlns:a16="http://schemas.microsoft.com/office/drawing/2014/main" id="{D30399DE-3C76-09F1-1877-662E9FE30908}"/>
+              </a:ext>
+            </a:extLst>
+          </p:cNvPr>
+          <p:cNvGrpSpPr/>
+          <p:nvPr/>
+        </p:nvGrpSpPr>
+        <p:grpSpPr>
+          <a:xfrm>
+            <a:off x="1397132" y="1212414"/>
+            <a:ext cx="698772" cy="387544"/>
+            <a:chOff x="1586362" y="1136475"/>
+            <a:chExt cx="698772" cy="387544"/>
+          </a:xfrm>
+        </p:grpSpPr>
+        <p:grpSp>
+          <p:nvGrpSpPr>
+            <p:cNvPr id="43" name="Group 42">
+              <a:extLst>
+                <a:ext uri="{FF2B5EF4-FFF2-40B4-BE49-F238E27FC236}">
+                  <a16:creationId xmlns:a16="http://schemas.microsoft.com/office/drawing/2014/main" id="{1D974854-98F0-3CD8-25A1-823E5192547F}"/>
+                </a:ext>
+              </a:extLst>
+            </p:cNvPr>
+            <p:cNvGrpSpPr/>
+            <p:nvPr/>
+          </p:nvGrpSpPr>
+          <p:grpSpPr>
+            <a:xfrm>
+              <a:off x="1586362" y="1136475"/>
+              <a:ext cx="698772" cy="387544"/>
+              <a:chOff x="-553441" y="1259384"/>
+              <a:chExt cx="698772" cy="387544"/>
+            </a:xfrm>
+          </p:grpSpPr>
+          <p:sp>
+            <p:nvSpPr>
+              <p:cNvPr id="5" name="Rectangle 4">
+                <a:extLst>
+                  <a:ext uri="{FF2B5EF4-FFF2-40B4-BE49-F238E27FC236}">
+                    <a16:creationId xmlns:a16="http://schemas.microsoft.com/office/drawing/2014/main" id="{B6ECA827-E587-0A90-13B1-AF43735A9F47}"/>
+                  </a:ext>
+                </a:extLst>
+              </p:cNvPr>
+              <p:cNvSpPr/>
+              <p:nvPr/>
+            </p:nvSpPr>
+            <p:spPr>
+              <a:xfrm>
+                <a:off x="-553441" y="1259384"/>
+                <a:ext cx="698772" cy="387544"/>
+              </a:xfrm>
+              <a:prstGeom prst="rect">
+                <a:avLst/>
+              </a:prstGeom>
+              <a:solidFill>
+                <a:schemeClr val="bg1"/>
+              </a:solidFill>
+              <a:ln w="9525">
+                <a:solidFill>
+                  <a:schemeClr val="tx1">
+                    <a:lumMod val="65000"/>
+                    <a:lumOff val="35000"/>
+                  </a:schemeClr>
+                </a:solidFill>
+              </a:ln>
+            </p:spPr>
+            <p:style>
+              <a:lnRef idx="2">
+                <a:schemeClr val="accent1">
+                  <a:shade val="15000"/>
+                </a:schemeClr>
+              </a:lnRef>
+              <a:fillRef idx="1">
+                <a:schemeClr val="accent1"/>
+              </a:fillRef>
+              <a:effectRef idx="0">
+                <a:schemeClr val="accent1"/>
+              </a:effectRef>
+              <a:fontRef idx="minor">
+                <a:schemeClr val="lt1"/>
+              </a:fontRef>
+            </p:style>
+            <p:txBody>
+              <a:bodyPr rtlCol="0" anchor="ctr"/>
+              <a:lstStyle/>
+              <a:p>
+                <a:pPr algn="ctr"/>
+                <a:endParaRPr lang="en-US"/>
+              </a:p>
+            </p:txBody>
+          </p:sp>
+          <p:sp>
+            <p:nvSpPr>
+              <p:cNvPr id="6" name="Rounded Rectangle 5">
+                <a:extLst>
+                  <a:ext uri="{FF2B5EF4-FFF2-40B4-BE49-F238E27FC236}">
+                    <a16:creationId xmlns:a16="http://schemas.microsoft.com/office/drawing/2014/main" id="{81CAE329-E594-4F6E-8488-19E2E9F64A0C}"/>
+                  </a:ext>
+                </a:extLst>
+              </p:cNvPr>
+              <p:cNvSpPr/>
+              <p:nvPr/>
+            </p:nvSpPr>
+            <p:spPr>
+              <a:xfrm rot="20083086">
+                <a:off x="-525224" y="1317983"/>
+                <a:ext cx="154288" cy="91263"/>
+              </a:xfrm>
+              <a:prstGeom prst="roundRect">
+                <a:avLst>
+                  <a:gd name="adj" fmla="val 47948"/>
+                </a:avLst>
+              </a:prstGeom>
+              <a:solidFill>
+                <a:schemeClr val="bg1">
+                  <a:lumMod val="85000"/>
+                </a:schemeClr>
+              </a:solidFill>
+              <a:ln w="9525">
+                <a:solidFill>
+                  <a:schemeClr val="tx1">
+                    <a:lumMod val="65000"/>
+                    <a:lumOff val="35000"/>
+                  </a:schemeClr>
+                </a:solidFill>
+              </a:ln>
+            </p:spPr>
+            <p:style>
+              <a:lnRef idx="2">
+                <a:schemeClr val="accent1">
+                  <a:shade val="15000"/>
+                </a:schemeClr>
+              </a:lnRef>
+              <a:fillRef idx="1">
+                <a:schemeClr val="accent1"/>
+              </a:fillRef>
+              <a:effectRef idx="0">
+                <a:schemeClr val="accent1"/>
+              </a:effectRef>
+              <a:fontRef idx="minor">
+                <a:schemeClr val="lt1"/>
+              </a:fontRef>
+            </p:style>
+            <p:txBody>
+              <a:bodyPr rtlCol="0" anchor="ctr"/>
+              <a:lstStyle/>
+              <a:p>
+                <a:pPr algn="ctr"/>
+                <a:endParaRPr lang="en-US" sz="800" dirty="0">
+                  <a:latin typeface="Helvetica" pitchFamily="2" charset="0"/>
+                </a:endParaRPr>
+              </a:p>
+            </p:txBody>
+          </p:sp>
+          <p:grpSp>
+            <p:nvGrpSpPr>
+              <p:cNvPr id="12" name="Group 11">
+                <a:extLst>
+                  <a:ext uri="{FF2B5EF4-FFF2-40B4-BE49-F238E27FC236}">
+                    <a16:creationId xmlns:a16="http://schemas.microsoft.com/office/drawing/2014/main" id="{E10B9F7A-4B04-C0F7-BB48-6D476EB2E3C5}"/>
+                  </a:ext>
+                </a:extLst>
+              </p:cNvPr>
+              <p:cNvGrpSpPr/>
+              <p:nvPr/>
+            </p:nvGrpSpPr>
+            <p:grpSpPr>
+              <a:xfrm rot="20042611">
+                <a:off x="-534672" y="1510090"/>
+                <a:ext cx="154288" cy="91263"/>
+                <a:chOff x="6979" y="1284864"/>
+                <a:chExt cx="588779" cy="348270"/>
+              </a:xfrm>
+            </p:grpSpPr>
+            <p:sp>
+              <p:nvSpPr>
+                <p:cNvPr id="9" name="Rounded Rectangle 8">
+                  <a:extLst>
+                    <a:ext uri="{FF2B5EF4-FFF2-40B4-BE49-F238E27FC236}">
+                      <a16:creationId xmlns:a16="http://schemas.microsoft.com/office/drawing/2014/main" id="{47E5287E-638F-8F7D-9418-73B3C9AC8597}"/>
+                    </a:ext>
+                  </a:extLst>
+                </p:cNvPr>
+                <p:cNvSpPr/>
+                <p:nvPr/>
+              </p:nvSpPr>
+              <p:spPr>
+                <a:xfrm>
+                  <a:off x="6979" y="1284864"/>
+                  <a:ext cx="588779" cy="348270"/>
+                </a:xfrm>
+                <a:prstGeom prst="roundRect">
+                  <a:avLst>
+                    <a:gd name="adj" fmla="val 47948"/>
+                  </a:avLst>
+                </a:prstGeom>
+                <a:solidFill>
+                  <a:schemeClr val="bg1"/>
+                </a:solidFill>
+                <a:ln w="9525">
+                  <a:solidFill>
+                    <a:schemeClr val="tx1">
+                      <a:lumMod val="65000"/>
+                      <a:lumOff val="35000"/>
+                    </a:schemeClr>
+                  </a:solidFill>
+                </a:ln>
+              </p:spPr>
+              <p:style>
+                <a:lnRef idx="2">
+                  <a:schemeClr val="accent1">
+                    <a:shade val="15000"/>
+                  </a:schemeClr>
+                </a:lnRef>
+                <a:fillRef idx="1">
+                  <a:schemeClr val="accent1"/>
+                </a:fillRef>
+                <a:effectRef idx="0">
+                  <a:schemeClr val="accent1"/>
+                </a:effectRef>
+                <a:fontRef idx="minor">
+                  <a:schemeClr val="lt1"/>
+                </a:fontRef>
+              </p:style>
+              <p:txBody>
+                <a:bodyPr rtlCol="0" anchor="ctr"/>
+                <a:lstStyle/>
+                <a:p>
+                  <a:pPr algn="ctr"/>
+                  <a:endParaRPr lang="en-US" sz="800" dirty="0">
+                    <a:latin typeface="Helvetica" pitchFamily="2" charset="0"/>
+                  </a:endParaRPr>
+                </a:p>
+              </p:txBody>
+            </p:sp>
+            <p:sp>
+              <p:nvSpPr>
+                <p:cNvPr id="10" name="Oval 9">
+                  <a:extLst>
+                    <a:ext uri="{FF2B5EF4-FFF2-40B4-BE49-F238E27FC236}">
+                      <a16:creationId xmlns:a16="http://schemas.microsoft.com/office/drawing/2014/main" id="{BDFEC878-195F-FB15-0BAA-8B3BCC18AE99}"/>
+                    </a:ext>
+                  </a:extLst>
+                </p:cNvPr>
+                <p:cNvSpPr/>
+                <p:nvPr/>
+              </p:nvSpPr>
+              <p:spPr>
+                <a:xfrm>
+                  <a:off x="325300" y="1353198"/>
+                  <a:ext cx="199597" cy="199596"/>
+                </a:xfrm>
+                <a:prstGeom prst="ellipse">
+                  <a:avLst/>
+                </a:prstGeom>
+                <a:noFill/>
+                <a:ln w="12700">
+                  <a:solidFill>
+                    <a:schemeClr val="accent4"/>
+                  </a:solidFill>
+                </a:ln>
+              </p:spPr>
+              <p:style>
+                <a:lnRef idx="2">
+                  <a:schemeClr val="accent1">
+                    <a:shade val="15000"/>
+                  </a:schemeClr>
+                </a:lnRef>
+                <a:fillRef idx="1">
+                  <a:schemeClr val="accent1"/>
+                </a:fillRef>
+                <a:effectRef idx="0">
+                  <a:schemeClr val="accent1"/>
+                </a:effectRef>
+                <a:fontRef idx="minor">
+                  <a:schemeClr val="lt1"/>
+                </a:fontRef>
+              </p:style>
+              <p:txBody>
+                <a:bodyPr rtlCol="0" anchor="ctr"/>
+                <a:lstStyle/>
+                <a:p>
+                  <a:pPr algn="ctr"/>
+                  <a:endParaRPr lang="en-US" sz="800">
+                    <a:latin typeface="Helvetica" pitchFamily="2" charset="0"/>
+                  </a:endParaRPr>
+                </a:p>
+              </p:txBody>
+            </p:sp>
+          </p:grpSp>
+          <p:grpSp>
+            <p:nvGrpSpPr>
+              <p:cNvPr id="14" name="Group 13">
+                <a:extLst>
+                  <a:ext uri="{FF2B5EF4-FFF2-40B4-BE49-F238E27FC236}">
+                    <a16:creationId xmlns:a16="http://schemas.microsoft.com/office/drawing/2014/main" id="{D9EAA81D-BE9F-8101-300E-6DC2500F1152}"/>
+                  </a:ext>
+                </a:extLst>
+              </p:cNvPr>
+              <p:cNvGrpSpPr/>
+              <p:nvPr/>
+            </p:nvGrpSpPr>
+            <p:grpSpPr>
+              <a:xfrm rot="488309">
+                <a:off x="-401566" y="1408102"/>
+                <a:ext cx="154288" cy="91263"/>
+                <a:chOff x="6979" y="1284864"/>
+                <a:chExt cx="588779" cy="348270"/>
+              </a:xfrm>
+            </p:grpSpPr>
+            <p:sp>
+              <p:nvSpPr>
+                <p:cNvPr id="16" name="Rounded Rectangle 15">
+                  <a:extLst>
+                    <a:ext uri="{FF2B5EF4-FFF2-40B4-BE49-F238E27FC236}">
+                      <a16:creationId xmlns:a16="http://schemas.microsoft.com/office/drawing/2014/main" id="{82C5D487-B011-CFD0-FC4C-C77D16BF6BFF}"/>
+                    </a:ext>
+                  </a:extLst>
+                </p:cNvPr>
+                <p:cNvSpPr/>
+                <p:nvPr/>
+              </p:nvSpPr>
+              <p:spPr>
+                <a:xfrm>
+                  <a:off x="6979" y="1284864"/>
+                  <a:ext cx="588779" cy="348270"/>
+                </a:xfrm>
+                <a:prstGeom prst="roundRect">
+                  <a:avLst>
+                    <a:gd name="adj" fmla="val 47948"/>
+                  </a:avLst>
+                </a:prstGeom>
+                <a:solidFill>
+                  <a:schemeClr val="bg1"/>
+                </a:solidFill>
+                <a:ln w="9525">
+                  <a:solidFill>
+                    <a:schemeClr val="tx1">
+                      <a:lumMod val="65000"/>
+                      <a:lumOff val="35000"/>
+                    </a:schemeClr>
+                  </a:solidFill>
+                </a:ln>
+              </p:spPr>
+              <p:style>
+                <a:lnRef idx="2">
+                  <a:schemeClr val="accent1">
+                    <a:shade val="15000"/>
+                  </a:schemeClr>
+                </a:lnRef>
+                <a:fillRef idx="1">
+                  <a:schemeClr val="accent1"/>
+                </a:fillRef>
+                <a:effectRef idx="0">
+                  <a:schemeClr val="accent1"/>
+                </a:effectRef>
+                <a:fontRef idx="minor">
+                  <a:schemeClr val="lt1"/>
+                </a:fontRef>
+              </p:style>
+              <p:txBody>
+                <a:bodyPr rtlCol="0" anchor="ctr"/>
+                <a:lstStyle/>
+                <a:p>
+                  <a:pPr algn="ctr"/>
+                  <a:endParaRPr lang="en-US" sz="800" dirty="0">
+                    <a:latin typeface="Helvetica" pitchFamily="2" charset="0"/>
+                  </a:endParaRPr>
+                </a:p>
+              </p:txBody>
+            </p:sp>
+            <p:sp>
+              <p:nvSpPr>
+                <p:cNvPr id="17" name="Oval 16">
+                  <a:extLst>
+                    <a:ext uri="{FF2B5EF4-FFF2-40B4-BE49-F238E27FC236}">
+                      <a16:creationId xmlns:a16="http://schemas.microsoft.com/office/drawing/2014/main" id="{5E53F40A-A921-B20D-F3D5-A0DDB2DDC037}"/>
+                    </a:ext>
+                  </a:extLst>
+                </p:cNvPr>
+                <p:cNvSpPr/>
+                <p:nvPr/>
+              </p:nvSpPr>
+              <p:spPr>
+                <a:xfrm>
+                  <a:off x="325300" y="1353198"/>
+                  <a:ext cx="199597" cy="199596"/>
+                </a:xfrm>
+                <a:prstGeom prst="ellipse">
+                  <a:avLst/>
+                </a:prstGeom>
+                <a:noFill/>
+                <a:ln w="12700">
+                  <a:solidFill>
+                    <a:schemeClr val="accent4"/>
+                  </a:solidFill>
+                </a:ln>
+              </p:spPr>
+              <p:style>
+                <a:lnRef idx="2">
+                  <a:schemeClr val="accent1">
+                    <a:shade val="15000"/>
+                  </a:schemeClr>
+                </a:lnRef>
+                <a:fillRef idx="1">
+                  <a:schemeClr val="accent1"/>
+                </a:fillRef>
+                <a:effectRef idx="0">
+                  <a:schemeClr val="accent1"/>
+                </a:effectRef>
+                <a:fontRef idx="minor">
+                  <a:schemeClr val="lt1"/>
+                </a:fontRef>
+              </p:style>
+              <p:txBody>
+                <a:bodyPr rtlCol="0" anchor="ctr"/>
+                <a:lstStyle/>
+                <a:p>
+                  <a:pPr algn="ctr"/>
+                  <a:endParaRPr lang="en-US" sz="800">
+                    <a:latin typeface="Helvetica" pitchFamily="2" charset="0"/>
+                  </a:endParaRPr>
+                </a:p>
+              </p:txBody>
+            </p:sp>
+          </p:grpSp>
+          <p:grpSp>
+            <p:nvGrpSpPr>
+              <p:cNvPr id="19" name="Group 18">
+                <a:extLst>
+                  <a:ext uri="{FF2B5EF4-FFF2-40B4-BE49-F238E27FC236}">
+                    <a16:creationId xmlns:a16="http://schemas.microsoft.com/office/drawing/2014/main" id="{6B7C5D85-9CF0-15BC-6885-5CB7B2BA3BB6}"/>
+                  </a:ext>
+                </a:extLst>
+              </p:cNvPr>
+              <p:cNvGrpSpPr/>
+              <p:nvPr/>
+            </p:nvGrpSpPr>
+            <p:grpSpPr>
+              <a:xfrm>
+                <a:off x="-333360" y="1525725"/>
+                <a:ext cx="154288" cy="91263"/>
+                <a:chOff x="6979" y="1284864"/>
+                <a:chExt cx="588779" cy="348270"/>
+              </a:xfrm>
+            </p:grpSpPr>
+            <p:sp>
+              <p:nvSpPr>
+                <p:cNvPr id="20" name="Rounded Rectangle 19">
+                  <a:extLst>
+                    <a:ext uri="{FF2B5EF4-FFF2-40B4-BE49-F238E27FC236}">
+                      <a16:creationId xmlns:a16="http://schemas.microsoft.com/office/drawing/2014/main" id="{F5DE6F2F-1F54-09C4-797C-415B1463757B}"/>
+                    </a:ext>
+                  </a:extLst>
+                </p:cNvPr>
+                <p:cNvSpPr/>
+                <p:nvPr/>
+              </p:nvSpPr>
+              <p:spPr>
+                <a:xfrm>
+                  <a:off x="6979" y="1284864"/>
+                  <a:ext cx="588779" cy="348270"/>
+                </a:xfrm>
+                <a:prstGeom prst="roundRect">
+                  <a:avLst>
+                    <a:gd name="adj" fmla="val 47948"/>
+                  </a:avLst>
+                </a:prstGeom>
+                <a:solidFill>
+                  <a:schemeClr val="bg1"/>
+                </a:solidFill>
+                <a:ln w="9525">
+                  <a:solidFill>
+                    <a:schemeClr val="tx1">
+                      <a:lumMod val="65000"/>
+                      <a:lumOff val="35000"/>
+                    </a:schemeClr>
+                  </a:solidFill>
+                </a:ln>
+              </p:spPr>
+              <p:style>
+                <a:lnRef idx="2">
+                  <a:schemeClr val="accent1">
+                    <a:shade val="15000"/>
+                  </a:schemeClr>
+                </a:lnRef>
+                <a:fillRef idx="1">
+                  <a:schemeClr val="accent1"/>
+                </a:fillRef>
+                <a:effectRef idx="0">
+                  <a:schemeClr val="accent1"/>
+                </a:effectRef>
+                <a:fontRef idx="minor">
+                  <a:schemeClr val="lt1"/>
+                </a:fontRef>
+              </p:style>
+              <p:txBody>
+                <a:bodyPr rtlCol="0" anchor="ctr"/>
+                <a:lstStyle/>
+                <a:p>
+                  <a:pPr algn="ctr"/>
+                  <a:endParaRPr lang="en-US" sz="800" dirty="0">
+                    <a:latin typeface="Helvetica" pitchFamily="2" charset="0"/>
+                  </a:endParaRPr>
+                </a:p>
+              </p:txBody>
+            </p:sp>
+            <p:sp>
+              <p:nvSpPr>
+                <p:cNvPr id="21" name="Oval 20">
+                  <a:extLst>
+                    <a:ext uri="{FF2B5EF4-FFF2-40B4-BE49-F238E27FC236}">
+                      <a16:creationId xmlns:a16="http://schemas.microsoft.com/office/drawing/2014/main" id="{9081DECA-5EEF-C3F6-475B-4DB61CB6CA7E}"/>
+                    </a:ext>
+                  </a:extLst>
+                </p:cNvPr>
+                <p:cNvSpPr/>
+                <p:nvPr/>
+              </p:nvSpPr>
+              <p:spPr>
+                <a:xfrm>
+                  <a:off x="325300" y="1353198"/>
+                  <a:ext cx="199597" cy="199596"/>
+                </a:xfrm>
+                <a:prstGeom prst="ellipse">
+                  <a:avLst/>
+                </a:prstGeom>
+                <a:noFill/>
+                <a:ln w="12700">
+                  <a:solidFill>
+                    <a:schemeClr val="accent4"/>
+                  </a:solidFill>
+                </a:ln>
+              </p:spPr>
+              <p:style>
+                <a:lnRef idx="2">
+                  <a:schemeClr val="accent1">
+                    <a:shade val="15000"/>
+                  </a:schemeClr>
+                </a:lnRef>
+                <a:fillRef idx="1">
+                  <a:schemeClr val="accent1"/>
+                </a:fillRef>
+                <a:effectRef idx="0">
+                  <a:schemeClr val="accent1"/>
+                </a:effectRef>
+                <a:fontRef idx="minor">
+                  <a:schemeClr val="lt1"/>
+                </a:fontRef>
+              </p:style>
+              <p:txBody>
+                <a:bodyPr rtlCol="0" anchor="ctr"/>
+                <a:lstStyle/>
+                <a:p>
+                  <a:pPr algn="ctr"/>
+                  <a:endParaRPr lang="en-US" sz="800">
+                    <a:latin typeface="Helvetica" pitchFamily="2" charset="0"/>
+                  </a:endParaRPr>
+                </a:p>
+              </p:txBody>
+            </p:sp>
+          </p:grpSp>
+          <p:sp>
+            <p:nvSpPr>
+              <p:cNvPr id="24" name="Rounded Rectangle 23">
+                <a:extLst>
+                  <a:ext uri="{FF2B5EF4-FFF2-40B4-BE49-F238E27FC236}">
+                    <a16:creationId xmlns:a16="http://schemas.microsoft.com/office/drawing/2014/main" id="{1C3CEC34-70AC-8EDE-DD11-C5C4D543EC2F}"/>
+                  </a:ext>
+                </a:extLst>
+              </p:cNvPr>
+              <p:cNvSpPr/>
+              <p:nvPr/>
+            </p:nvSpPr>
+            <p:spPr>
+              <a:xfrm rot="20083086">
+                <a:off x="-206809" y="1378937"/>
+                <a:ext cx="154288" cy="91263"/>
+              </a:xfrm>
+              <a:prstGeom prst="roundRect">
+                <a:avLst>
+                  <a:gd name="adj" fmla="val 47948"/>
+                </a:avLst>
+              </a:prstGeom>
+              <a:solidFill>
+                <a:schemeClr val="bg1">
+                  <a:lumMod val="85000"/>
+                </a:schemeClr>
+              </a:solidFill>
+              <a:ln w="9525">
+                <a:solidFill>
+                  <a:schemeClr val="tx1">
+                    <a:lumMod val="65000"/>
+                    <a:lumOff val="35000"/>
+                  </a:schemeClr>
+                </a:solidFill>
+              </a:ln>
+            </p:spPr>
+            <p:style>
+              <a:lnRef idx="2">
+                <a:schemeClr val="accent1">
+                  <a:shade val="15000"/>
+                </a:schemeClr>
+              </a:lnRef>
+              <a:fillRef idx="1">
+                <a:schemeClr val="accent1"/>
+              </a:fillRef>
+              <a:effectRef idx="0">
+                <a:schemeClr val="accent1"/>
+              </a:effectRef>
+              <a:fontRef idx="minor">
+                <a:schemeClr val="lt1"/>
+              </a:fontRef>
+            </p:style>
+            <p:txBody>
+              <a:bodyPr rtlCol="0" anchor="ctr"/>
+              <a:lstStyle/>
+              <a:p>
+                <a:pPr algn="ctr"/>
+                <a:endParaRPr lang="en-US" sz="800" dirty="0">
+                  <a:latin typeface="Helvetica" pitchFamily="2" charset="0"/>
+                </a:endParaRPr>
+              </a:p>
+            </p:txBody>
+          </p:sp>
+          <p:grpSp>
+            <p:nvGrpSpPr>
+              <p:cNvPr id="26" name="Group 25">
+                <a:extLst>
+                  <a:ext uri="{FF2B5EF4-FFF2-40B4-BE49-F238E27FC236}">
+                    <a16:creationId xmlns:a16="http://schemas.microsoft.com/office/drawing/2014/main" id="{15111542-01E3-7829-D0DC-4E71D7FE504E}"/>
+                  </a:ext>
+                </a:extLst>
+              </p:cNvPr>
+              <p:cNvGrpSpPr/>
+              <p:nvPr/>
+            </p:nvGrpSpPr>
+            <p:grpSpPr>
+              <a:xfrm rot="488309">
+                <a:off x="-148212" y="1522195"/>
+                <a:ext cx="154288" cy="91263"/>
+                <a:chOff x="6979" y="1284864"/>
+                <a:chExt cx="588779" cy="348270"/>
+              </a:xfrm>
+            </p:grpSpPr>
+            <p:sp>
+              <p:nvSpPr>
+                <p:cNvPr id="27" name="Rounded Rectangle 26">
+                  <a:extLst>
+                    <a:ext uri="{FF2B5EF4-FFF2-40B4-BE49-F238E27FC236}">
+                      <a16:creationId xmlns:a16="http://schemas.microsoft.com/office/drawing/2014/main" id="{BE8C29B7-9AAD-5E92-C1D1-A1B09C3DEEC0}"/>
+                    </a:ext>
+                  </a:extLst>
+                </p:cNvPr>
+                <p:cNvSpPr/>
+                <p:nvPr/>
+              </p:nvSpPr>
+              <p:spPr>
+                <a:xfrm>
+                  <a:off x="6979" y="1284864"/>
+                  <a:ext cx="588779" cy="348270"/>
+                </a:xfrm>
+                <a:prstGeom prst="roundRect">
+                  <a:avLst>
+                    <a:gd name="adj" fmla="val 47948"/>
+                  </a:avLst>
+                </a:prstGeom>
+                <a:solidFill>
+                  <a:schemeClr val="bg1"/>
+                </a:solidFill>
+                <a:ln w="9525">
+                  <a:solidFill>
+                    <a:schemeClr val="tx1">
+                      <a:lumMod val="65000"/>
+                      <a:lumOff val="35000"/>
+                    </a:schemeClr>
+                  </a:solidFill>
+                </a:ln>
+              </p:spPr>
+              <p:style>
+                <a:lnRef idx="2">
+                  <a:schemeClr val="accent1">
+                    <a:shade val="15000"/>
+                  </a:schemeClr>
+                </a:lnRef>
+                <a:fillRef idx="1">
+                  <a:schemeClr val="accent1"/>
+                </a:fillRef>
+                <a:effectRef idx="0">
+                  <a:schemeClr val="accent1"/>
+                </a:effectRef>
+                <a:fontRef idx="minor">
+                  <a:schemeClr val="lt1"/>
+                </a:fontRef>
+              </p:style>
+              <p:txBody>
+                <a:bodyPr rtlCol="0" anchor="ctr"/>
+                <a:lstStyle/>
+                <a:p>
+                  <a:pPr algn="ctr"/>
+                  <a:endParaRPr lang="en-US" sz="800" dirty="0">
+                    <a:latin typeface="Helvetica" pitchFamily="2" charset="0"/>
+                  </a:endParaRPr>
+                </a:p>
+              </p:txBody>
+            </p:sp>
+            <p:sp>
+              <p:nvSpPr>
+                <p:cNvPr id="30" name="Oval 29">
+                  <a:extLst>
+                    <a:ext uri="{FF2B5EF4-FFF2-40B4-BE49-F238E27FC236}">
+                      <a16:creationId xmlns:a16="http://schemas.microsoft.com/office/drawing/2014/main" id="{3CED5866-EC48-6638-8A2A-BD9B85987376}"/>
+                    </a:ext>
+                  </a:extLst>
+                </p:cNvPr>
+                <p:cNvSpPr/>
+                <p:nvPr/>
+              </p:nvSpPr>
+              <p:spPr>
+                <a:xfrm>
+                  <a:off x="325300" y="1353198"/>
+                  <a:ext cx="199597" cy="199596"/>
+                </a:xfrm>
+                <a:prstGeom prst="ellipse">
+                  <a:avLst/>
+                </a:prstGeom>
+                <a:noFill/>
+                <a:ln w="12700">
+                  <a:solidFill>
+                    <a:schemeClr val="accent4"/>
+                  </a:solidFill>
+                </a:ln>
+              </p:spPr>
+              <p:style>
+                <a:lnRef idx="2">
+                  <a:schemeClr val="accent1">
+                    <a:shade val="15000"/>
+                  </a:schemeClr>
+                </a:lnRef>
+                <a:fillRef idx="1">
+                  <a:schemeClr val="accent1"/>
+                </a:fillRef>
+                <a:effectRef idx="0">
+                  <a:schemeClr val="accent1"/>
+                </a:effectRef>
+                <a:fontRef idx="minor">
+                  <a:schemeClr val="lt1"/>
+                </a:fontRef>
+              </p:style>
+              <p:txBody>
+                <a:bodyPr rtlCol="0" anchor="ctr"/>
+                <a:lstStyle/>
+                <a:p>
+                  <a:pPr algn="ctr"/>
+                  <a:endParaRPr lang="en-US" sz="800">
+                    <a:latin typeface="Helvetica" pitchFamily="2" charset="0"/>
+                  </a:endParaRPr>
+                </a:p>
+              </p:txBody>
+            </p:sp>
+          </p:grpSp>
+          <p:grpSp>
+            <p:nvGrpSpPr>
+              <p:cNvPr id="31" name="Group 30">
+                <a:extLst>
+                  <a:ext uri="{FF2B5EF4-FFF2-40B4-BE49-F238E27FC236}">
+                    <a16:creationId xmlns:a16="http://schemas.microsoft.com/office/drawing/2014/main" id="{39FCCAC6-8AC2-2DCE-3B41-F0FB3467EA54}"/>
+                  </a:ext>
+                </a:extLst>
+              </p:cNvPr>
+              <p:cNvGrpSpPr/>
+              <p:nvPr/>
+            </p:nvGrpSpPr>
+            <p:grpSpPr>
+              <a:xfrm rot="1532720">
+                <a:off x="-66495" y="1296574"/>
+                <a:ext cx="154288" cy="91263"/>
+                <a:chOff x="6979" y="1284864"/>
+                <a:chExt cx="588779" cy="348270"/>
+              </a:xfrm>
+            </p:grpSpPr>
+            <p:sp>
+              <p:nvSpPr>
+                <p:cNvPr id="32" name="Rounded Rectangle 31">
+                  <a:extLst>
+                    <a:ext uri="{FF2B5EF4-FFF2-40B4-BE49-F238E27FC236}">
+                      <a16:creationId xmlns:a16="http://schemas.microsoft.com/office/drawing/2014/main" id="{090CEE40-CFAC-55FB-813E-627002BFB7BD}"/>
+                    </a:ext>
+                  </a:extLst>
+                </p:cNvPr>
+                <p:cNvSpPr/>
+                <p:nvPr/>
+              </p:nvSpPr>
+              <p:spPr>
+                <a:xfrm>
+                  <a:off x="6979" y="1284864"/>
+                  <a:ext cx="588779" cy="348270"/>
+                </a:xfrm>
+                <a:prstGeom prst="roundRect">
+                  <a:avLst>
+                    <a:gd name="adj" fmla="val 47948"/>
+                  </a:avLst>
+                </a:prstGeom>
+                <a:solidFill>
+                  <a:schemeClr val="bg1"/>
+                </a:solidFill>
+                <a:ln w="9525">
+                  <a:solidFill>
+                    <a:schemeClr val="tx1">
+                      <a:lumMod val="65000"/>
+                      <a:lumOff val="35000"/>
+                    </a:schemeClr>
+                  </a:solidFill>
+                </a:ln>
+              </p:spPr>
+              <p:style>
+                <a:lnRef idx="2">
+                  <a:schemeClr val="accent1">
+                    <a:shade val="15000"/>
+                  </a:schemeClr>
+                </a:lnRef>
+                <a:fillRef idx="1">
+                  <a:schemeClr val="accent1"/>
+                </a:fillRef>
+                <a:effectRef idx="0">
+                  <a:schemeClr val="accent1"/>
+                </a:effectRef>
+                <a:fontRef idx="minor">
+                  <a:schemeClr val="lt1"/>
+                </a:fontRef>
+              </p:style>
+              <p:txBody>
+                <a:bodyPr rtlCol="0" anchor="ctr"/>
+                <a:lstStyle/>
+                <a:p>
+                  <a:pPr algn="ctr"/>
+                  <a:endParaRPr lang="en-US" sz="800" dirty="0">
+                    <a:latin typeface="Helvetica" pitchFamily="2" charset="0"/>
+                  </a:endParaRPr>
+                </a:p>
+              </p:txBody>
+            </p:sp>
+            <p:sp>
+              <p:nvSpPr>
+                <p:cNvPr id="33" name="Oval 32">
+                  <a:extLst>
+                    <a:ext uri="{FF2B5EF4-FFF2-40B4-BE49-F238E27FC236}">
+                      <a16:creationId xmlns:a16="http://schemas.microsoft.com/office/drawing/2014/main" id="{80D54229-DEF9-E2A1-716C-F33CBBBB5503}"/>
+                    </a:ext>
+                  </a:extLst>
+                </p:cNvPr>
+                <p:cNvSpPr/>
+                <p:nvPr/>
+              </p:nvSpPr>
+              <p:spPr>
+                <a:xfrm>
+                  <a:off x="325300" y="1353198"/>
+                  <a:ext cx="199597" cy="199596"/>
+                </a:xfrm>
+                <a:prstGeom prst="ellipse">
+                  <a:avLst/>
+                </a:prstGeom>
+                <a:noFill/>
+                <a:ln w="12700">
+                  <a:solidFill>
+                    <a:schemeClr val="accent4"/>
+                  </a:solidFill>
+                </a:ln>
+              </p:spPr>
+              <p:style>
+                <a:lnRef idx="2">
+                  <a:schemeClr val="accent1">
+                    <a:shade val="15000"/>
+                  </a:schemeClr>
+                </a:lnRef>
+                <a:fillRef idx="1">
+                  <a:schemeClr val="accent1"/>
+                </a:fillRef>
+                <a:effectRef idx="0">
+                  <a:schemeClr val="accent1"/>
+                </a:effectRef>
+                <a:fontRef idx="minor">
+                  <a:schemeClr val="lt1"/>
+                </a:fontRef>
+              </p:style>
+              <p:txBody>
+                <a:bodyPr rtlCol="0" anchor="ctr"/>
+                <a:lstStyle/>
+                <a:p>
+                  <a:pPr algn="ctr"/>
+                  <a:endParaRPr lang="en-US" sz="800">
+                    <a:latin typeface="Helvetica" pitchFamily="2" charset="0"/>
+                  </a:endParaRPr>
+                </a:p>
+              </p:txBody>
+            </p:sp>
+          </p:grpSp>
+          <p:sp>
+            <p:nvSpPr>
+              <p:cNvPr id="34" name="Rounded Rectangle 33">
+                <a:extLst>
+                  <a:ext uri="{FF2B5EF4-FFF2-40B4-BE49-F238E27FC236}">
+                    <a16:creationId xmlns:a16="http://schemas.microsoft.com/office/drawing/2014/main" id="{4D95487F-104A-0820-1211-4788698F759E}"/>
+                  </a:ext>
+                </a:extLst>
+              </p:cNvPr>
+              <p:cNvSpPr/>
+              <p:nvPr/>
+            </p:nvSpPr>
+            <p:spPr>
+              <a:xfrm>
+                <a:off x="-339873" y="1290171"/>
+                <a:ext cx="154288" cy="91263"/>
+              </a:xfrm>
+              <a:prstGeom prst="roundRect">
+                <a:avLst>
+                  <a:gd name="adj" fmla="val 47948"/>
+                </a:avLst>
+              </a:prstGeom>
+              <a:solidFill>
+                <a:schemeClr val="bg1"/>
+              </a:solidFill>
+              <a:ln w="9525">
+                <a:solidFill>
+                  <a:schemeClr val="tx1">
+                    <a:lumMod val="65000"/>
+                    <a:lumOff val="35000"/>
+                  </a:schemeClr>
+                </a:solidFill>
+              </a:ln>
+            </p:spPr>
+            <p:style>
+              <a:lnRef idx="2">
+                <a:schemeClr val="accent1">
+                  <a:shade val="15000"/>
+                </a:schemeClr>
+              </a:lnRef>
+              <a:fillRef idx="1">
+                <a:schemeClr val="accent1"/>
+              </a:fillRef>
+              <a:effectRef idx="0">
+                <a:schemeClr val="accent1"/>
+              </a:effectRef>
+              <a:fontRef idx="minor">
+                <a:schemeClr val="lt1"/>
+              </a:fontRef>
+            </p:style>
+            <p:txBody>
+              <a:bodyPr rtlCol="0" anchor="ctr"/>
+              <a:lstStyle/>
+              <a:p>
+                <a:pPr algn="ctr"/>
+                <a:endParaRPr lang="en-US" sz="800" dirty="0">
+                  <a:latin typeface="Helvetica" pitchFamily="2" charset="0"/>
+                </a:endParaRPr>
+              </a:p>
+            </p:txBody>
+          </p:sp>
+          <p:grpSp>
+            <p:nvGrpSpPr>
+              <p:cNvPr id="35" name="Group 34">
+                <a:extLst>
+                  <a:ext uri="{FF2B5EF4-FFF2-40B4-BE49-F238E27FC236}">
+                    <a16:creationId xmlns:a16="http://schemas.microsoft.com/office/drawing/2014/main" id="{38758E8C-AD59-B895-5A8C-1FE351C2A536}"/>
+                  </a:ext>
+                </a:extLst>
+              </p:cNvPr>
+              <p:cNvGrpSpPr/>
+              <p:nvPr/>
+            </p:nvGrpSpPr>
+            <p:grpSpPr>
+              <a:xfrm rot="13005164">
+                <a:off x="-23210" y="1449929"/>
+                <a:ext cx="154288" cy="91263"/>
+                <a:chOff x="6979" y="1284864"/>
+                <a:chExt cx="588779" cy="348270"/>
+              </a:xfrm>
+            </p:grpSpPr>
+            <p:sp>
+              <p:nvSpPr>
+                <p:cNvPr id="40" name="Rounded Rectangle 39">
+                  <a:extLst>
+                    <a:ext uri="{FF2B5EF4-FFF2-40B4-BE49-F238E27FC236}">
+                      <a16:creationId xmlns:a16="http://schemas.microsoft.com/office/drawing/2014/main" id="{0BFA8FFA-713C-FCD0-55D7-FB7A456E4073}"/>
+                    </a:ext>
+                  </a:extLst>
+                </p:cNvPr>
+                <p:cNvSpPr/>
+                <p:nvPr/>
+              </p:nvSpPr>
+              <p:spPr>
+                <a:xfrm>
+                  <a:off x="6979" y="1284864"/>
+                  <a:ext cx="588779" cy="348270"/>
+                </a:xfrm>
+                <a:prstGeom prst="roundRect">
+                  <a:avLst>
+                    <a:gd name="adj" fmla="val 47948"/>
+                  </a:avLst>
+                </a:prstGeom>
+                <a:solidFill>
+                  <a:schemeClr val="bg1"/>
+                </a:solidFill>
+                <a:ln w="9525">
+                  <a:solidFill>
+                    <a:schemeClr val="tx1">
+                      <a:lumMod val="65000"/>
+                      <a:lumOff val="35000"/>
+                    </a:schemeClr>
+                  </a:solidFill>
+                </a:ln>
+              </p:spPr>
+              <p:style>
+                <a:lnRef idx="2">
+                  <a:schemeClr val="accent1">
+                    <a:shade val="15000"/>
+                  </a:schemeClr>
+                </a:lnRef>
+                <a:fillRef idx="1">
+                  <a:schemeClr val="accent1"/>
+                </a:fillRef>
+                <a:effectRef idx="0">
+                  <a:schemeClr val="accent1"/>
+                </a:effectRef>
+                <a:fontRef idx="minor">
+                  <a:schemeClr val="lt1"/>
+                </a:fontRef>
+              </p:style>
+              <p:txBody>
+                <a:bodyPr rtlCol="0" anchor="ctr"/>
+                <a:lstStyle/>
+                <a:p>
+                  <a:pPr algn="ctr"/>
+                  <a:endParaRPr lang="en-US" sz="800" dirty="0">
+                    <a:latin typeface="Helvetica" pitchFamily="2" charset="0"/>
+                  </a:endParaRPr>
+                </a:p>
+              </p:txBody>
+            </p:sp>
+            <p:sp>
+              <p:nvSpPr>
+                <p:cNvPr id="41" name="Oval 40">
+                  <a:extLst>
+                    <a:ext uri="{FF2B5EF4-FFF2-40B4-BE49-F238E27FC236}">
+                      <a16:creationId xmlns:a16="http://schemas.microsoft.com/office/drawing/2014/main" id="{6DBD76DA-0D4A-51D0-78A2-1EB57CFF6BB2}"/>
+                    </a:ext>
+                  </a:extLst>
+                </p:cNvPr>
+                <p:cNvSpPr/>
+                <p:nvPr/>
+              </p:nvSpPr>
+              <p:spPr>
+                <a:xfrm>
+                  <a:off x="325300" y="1353198"/>
+                  <a:ext cx="199597" cy="199596"/>
+                </a:xfrm>
+                <a:prstGeom prst="ellipse">
+                  <a:avLst/>
+                </a:prstGeom>
+                <a:noFill/>
+                <a:ln w="12700">
+                  <a:solidFill>
+                    <a:schemeClr val="accent4"/>
+                  </a:solidFill>
+                </a:ln>
+              </p:spPr>
+              <p:style>
+                <a:lnRef idx="2">
+                  <a:schemeClr val="accent1">
+                    <a:shade val="15000"/>
+                  </a:schemeClr>
+                </a:lnRef>
+                <a:fillRef idx="1">
+                  <a:schemeClr val="accent1"/>
+                </a:fillRef>
+                <a:effectRef idx="0">
+                  <a:schemeClr val="accent1"/>
+                </a:effectRef>
+                <a:fontRef idx="minor">
+                  <a:schemeClr val="lt1"/>
+                </a:fontRef>
+              </p:style>
+              <p:txBody>
+                <a:bodyPr rtlCol="0" anchor="ctr"/>
+                <a:lstStyle/>
+                <a:p>
+                  <a:pPr algn="ctr"/>
+                  <a:endParaRPr lang="en-US" sz="800">
+                    <a:latin typeface="Helvetica" pitchFamily="2" charset="0"/>
+                  </a:endParaRPr>
+                </a:p>
+              </p:txBody>
+            </p:sp>
+          </p:grpSp>
+        </p:grpSp>
+        <p:sp>
+          <p:nvSpPr>
+            <p:cNvPr id="89" name="Oval 88">
+              <a:extLst>
+                <a:ext uri="{FF2B5EF4-FFF2-40B4-BE49-F238E27FC236}">
+                  <a16:creationId xmlns:a16="http://schemas.microsoft.com/office/drawing/2014/main" id="{6DC06750-95E0-32D9-C7E2-185BEC2801EE}"/>
+                </a:ext>
+              </a:extLst>
+            </p:cNvPr>
+            <p:cNvSpPr/>
+            <p:nvPr/>
+          </p:nvSpPr>
+          <p:spPr>
+            <a:xfrm rot="488309">
+              <a:off x="1881681" y="1187082"/>
+              <a:ext cx="52304" cy="52303"/>
+            </a:xfrm>
+            <a:prstGeom prst="ellipse">
+              <a:avLst/>
+            </a:prstGeom>
+            <a:noFill/>
+            <a:ln w="12700">
+              <a:solidFill>
+                <a:schemeClr val="accent4"/>
+              </a:solidFill>
+            </a:ln>
+          </p:spPr>
+          <p:style>
+            <a:lnRef idx="2">
+              <a:schemeClr val="accent1">
+                <a:shade val="15000"/>
+              </a:schemeClr>
+            </a:lnRef>
+            <a:fillRef idx="1">
+              <a:schemeClr val="accent1"/>
+            </a:fillRef>
+            <a:effectRef idx="0">
+              <a:schemeClr val="accent1"/>
+            </a:effectRef>
+            <a:fontRef idx="minor">
+              <a:schemeClr val="lt1"/>
+            </a:fontRef>
+          </p:style>
+          <p:txBody>
+            <a:bodyPr rtlCol="0" anchor="ctr"/>
+            <a:lstStyle/>
+            <a:p>
+              <a:pPr algn="ctr"/>
+              <a:endParaRPr lang="en-US" sz="800">
+                <a:latin typeface="Helvetica" pitchFamily="2" charset="0"/>
+              </a:endParaRPr>
+            </a:p>
+          </p:txBody>
+        </p:sp>
+      </p:grpSp>
     </p:spTree>
     <p:extLst>
       <p:ext uri="{BB962C8B-B14F-4D97-AF65-F5344CB8AC3E}">

</xml_diff>